<commit_message>
feat: add comprehensive ER diagram and data dictionary to GitHub repository homepage
</commit_message>
<xml_diff>
--- a/QuizSphere_Master_Review_1_and_2.pptx
+++ b/QuizSphere_Master_Review_1_and_2.pptx
@@ -5,25 +5,25 @@
     <p:sldMasterId id="2147483648" r:id="rId1"/>
   </p:sldMasterIdLst>
   <p:sldIdLst>
-    <p:sldId id="256" r:id="rId7"/>
-    <p:sldId id="257" r:id="rId8"/>
-    <p:sldId id="258" r:id="rId9"/>
-    <p:sldId id="259" r:id="rId10"/>
-    <p:sldId id="260" r:id="rId11"/>
-    <p:sldId id="261" r:id="rId12"/>
-    <p:sldId id="262" r:id="rId13"/>
-    <p:sldId id="263" r:id="rId14"/>
-    <p:sldId id="264" r:id="rId15"/>
-    <p:sldId id="265" r:id="rId16"/>
-    <p:sldId id="266" r:id="rId17"/>
-    <p:sldId id="267" r:id="rId18"/>
-    <p:sldId id="268" r:id="rId19"/>
-    <p:sldId id="269" r:id="rId20"/>
-    <p:sldId id="270" r:id="rId21"/>
-    <p:sldId id="271" r:id="rId22"/>
-    <p:sldId id="272" r:id="rId23"/>
+    <p:sldId id="256" r:id="rId2"/>
+    <p:sldId id="257" r:id="rId3"/>
+    <p:sldId id="258" r:id="rId4"/>
+    <p:sldId id="259" r:id="rId5"/>
+    <p:sldId id="260" r:id="rId6"/>
+    <p:sldId id="261" r:id="rId7"/>
+    <p:sldId id="262" r:id="rId8"/>
+    <p:sldId id="263" r:id="rId9"/>
+    <p:sldId id="264" r:id="rId10"/>
+    <p:sldId id="265" r:id="rId11"/>
+    <p:sldId id="266" r:id="rId12"/>
+    <p:sldId id="267" r:id="rId13"/>
+    <p:sldId id="268" r:id="rId14"/>
+    <p:sldId id="269" r:id="rId15"/>
+    <p:sldId id="270" r:id="rId16"/>
+    <p:sldId id="271" r:id="rId17"/>
+    <p:sldId id="272" r:id="rId18"/>
   </p:sldIdLst>
-  <p:sldSz cx="12191695" cy="6858000" type="screen4x3"/>
+  <p:sldSz cx="12192000" cy="6858000"/>
   <p:notesSz cx="6858000" cy="9144000"/>
   <p:defaultTextStyle>
     <a:defPPr>
@@ -120,6 +120,22 @@
       </a:defRPr>
     </a:lvl9pPr>
   </p:defaultTextStyle>
+  <p:extLst>
+    <p:ext uri="{EFAFB233-063F-42B5-8137-9DF3F51BA10A}">
+      <p15:sldGuideLst xmlns:p15="http://schemas.microsoft.com/office/powerpoint/2012/main">
+        <p15:guide id="1" orient="horz" pos="2160">
+          <p15:clr>
+            <a:srgbClr val="A4A3A4"/>
+          </p15:clr>
+        </p15:guide>
+        <p15:guide id="2" pos="2880">
+          <p15:clr>
+            <a:srgbClr val="A4A3A4"/>
+          </p15:clr>
+        </p15:guide>
+      </p15:sldGuideLst>
+    </p:ext>
+  </p:extLst>
 </p:presentation>
 </file>
 
@@ -161,10 +177,9 @@
           <a:lstStyle/>
           <a:p>
             <a:r>
-              <a:rPr lang="en-US" smtClean="0"/>
+              <a:rPr lang="en-US"/>
               <a:t>Click to edit Master title style</a:t>
             </a:r>
-            <a:endParaRPr lang="en-US"/>
           </a:p>
         </p:txBody>
       </p:sp>
@@ -280,10 +295,9 @@
           </a:lstStyle>
           <a:p>
             <a:r>
-              <a:rPr lang="en-US" smtClean="0"/>
+              <a:rPr lang="en-US"/>
               <a:t>Click to edit Master subtitle style</a:t>
             </a:r>
-            <a:endParaRPr lang="en-US"/>
           </a:p>
         </p:txBody>
       </p:sp>
@@ -304,7 +318,7 @@
           <a:p>
             <a:fld id="{5BCAD085-E8A6-8845-BD4E-CB4CCA059FC4}" type="datetimeFigureOut">
               <a:rPr lang="en-US" smtClean="0"/>
-              <a:t>1/27/13</a:t>
+              <a:t>10/20/2026</a:t>
             </a:fld>
             <a:endParaRPr lang="en-US"/>
           </a:p>
@@ -398,10 +412,9 @@
           <a:lstStyle/>
           <a:p>
             <a:r>
-              <a:rPr lang="en-US" smtClean="0"/>
+              <a:rPr lang="en-US"/>
               <a:t>Click to edit Master title style</a:t>
             </a:r>
-            <a:endParaRPr lang="en-US"/>
           </a:p>
         </p:txBody>
       </p:sp>
@@ -422,38 +435,37 @@
           <a:p>
             <a:pPr lvl="0"/>
             <a:r>
-              <a:rPr lang="en-US" smtClean="0"/>
+              <a:rPr lang="en-US"/>
               <a:t>Click to edit Master text styles</a:t>
             </a:r>
           </a:p>
           <a:p>
             <a:pPr lvl="1"/>
             <a:r>
-              <a:rPr lang="en-US" smtClean="0"/>
+              <a:rPr lang="en-US"/>
               <a:t>Second level</a:t>
             </a:r>
           </a:p>
           <a:p>
             <a:pPr lvl="2"/>
             <a:r>
-              <a:rPr lang="en-US" smtClean="0"/>
+              <a:rPr lang="en-US"/>
               <a:t>Third level</a:t>
             </a:r>
           </a:p>
           <a:p>
             <a:pPr lvl="3"/>
             <a:r>
-              <a:rPr lang="en-US" smtClean="0"/>
+              <a:rPr lang="en-US"/>
               <a:t>Fourth level</a:t>
             </a:r>
           </a:p>
           <a:p>
             <a:pPr lvl="4"/>
             <a:r>
-              <a:rPr lang="en-US" smtClean="0"/>
+              <a:rPr lang="en-US"/>
               <a:t>Fifth level</a:t>
             </a:r>
-            <a:endParaRPr lang="en-US"/>
           </a:p>
         </p:txBody>
       </p:sp>
@@ -474,7 +486,7 @@
           <a:p>
             <a:fld id="{5BCAD085-E8A6-8845-BD4E-CB4CCA059FC4}" type="datetimeFigureOut">
               <a:rPr lang="en-US" smtClean="0"/>
-              <a:t>1/27/13</a:t>
+              <a:t>10/20/2026</a:t>
             </a:fld>
             <a:endParaRPr lang="en-US"/>
           </a:p>
@@ -573,10 +585,9 @@
           <a:lstStyle/>
           <a:p>
             <a:r>
-              <a:rPr lang="en-US" smtClean="0"/>
+              <a:rPr lang="en-US"/>
               <a:t>Click to edit Master title style</a:t>
             </a:r>
-            <a:endParaRPr lang="en-US"/>
           </a:p>
         </p:txBody>
       </p:sp>
@@ -602,38 +613,37 @@
           <a:p>
             <a:pPr lvl="0"/>
             <a:r>
-              <a:rPr lang="en-US" smtClean="0"/>
+              <a:rPr lang="en-US"/>
               <a:t>Click to edit Master text styles</a:t>
             </a:r>
           </a:p>
           <a:p>
             <a:pPr lvl="1"/>
             <a:r>
-              <a:rPr lang="en-US" smtClean="0"/>
+              <a:rPr lang="en-US"/>
               <a:t>Second level</a:t>
             </a:r>
           </a:p>
           <a:p>
             <a:pPr lvl="2"/>
             <a:r>
-              <a:rPr lang="en-US" smtClean="0"/>
+              <a:rPr lang="en-US"/>
               <a:t>Third level</a:t>
             </a:r>
           </a:p>
           <a:p>
             <a:pPr lvl="3"/>
             <a:r>
-              <a:rPr lang="en-US" smtClean="0"/>
+              <a:rPr lang="en-US"/>
               <a:t>Fourth level</a:t>
             </a:r>
           </a:p>
           <a:p>
             <a:pPr lvl="4"/>
             <a:r>
-              <a:rPr lang="en-US" smtClean="0"/>
+              <a:rPr lang="en-US"/>
               <a:t>Fifth level</a:t>
             </a:r>
-            <a:endParaRPr lang="en-US"/>
           </a:p>
         </p:txBody>
       </p:sp>
@@ -654,7 +664,7 @@
           <a:p>
             <a:fld id="{5BCAD085-E8A6-8845-BD4E-CB4CCA059FC4}" type="datetimeFigureOut">
               <a:rPr lang="en-US" smtClean="0"/>
-              <a:t>1/27/13</a:t>
+              <a:t>10/20/2026</a:t>
             </a:fld>
             <a:endParaRPr lang="en-US"/>
           </a:p>
@@ -748,10 +758,9 @@
           <a:lstStyle/>
           <a:p>
             <a:r>
-              <a:rPr lang="en-US" smtClean="0"/>
+              <a:rPr lang="en-US"/>
               <a:t>Click to edit Master title style</a:t>
             </a:r>
-            <a:endParaRPr lang="en-US"/>
           </a:p>
         </p:txBody>
       </p:sp>
@@ -772,38 +781,37 @@
           <a:p>
             <a:pPr lvl="0"/>
             <a:r>
-              <a:rPr lang="en-US" smtClean="0"/>
+              <a:rPr lang="en-US"/>
               <a:t>Click to edit Master text styles</a:t>
             </a:r>
           </a:p>
           <a:p>
             <a:pPr lvl="1"/>
             <a:r>
-              <a:rPr lang="en-US" smtClean="0"/>
+              <a:rPr lang="en-US"/>
               <a:t>Second level</a:t>
             </a:r>
           </a:p>
           <a:p>
             <a:pPr lvl="2"/>
             <a:r>
-              <a:rPr lang="en-US" smtClean="0"/>
+              <a:rPr lang="en-US"/>
               <a:t>Third level</a:t>
             </a:r>
           </a:p>
           <a:p>
             <a:pPr lvl="3"/>
             <a:r>
-              <a:rPr lang="en-US" smtClean="0"/>
+              <a:rPr lang="en-US"/>
               <a:t>Fourth level</a:t>
             </a:r>
           </a:p>
           <a:p>
             <a:pPr lvl="4"/>
             <a:r>
-              <a:rPr lang="en-US" smtClean="0"/>
+              <a:rPr lang="en-US"/>
               <a:t>Fifth level</a:t>
             </a:r>
-            <a:endParaRPr lang="en-US"/>
           </a:p>
         </p:txBody>
       </p:sp>
@@ -824,7 +832,7 @@
           <a:p>
             <a:fld id="{5BCAD085-E8A6-8845-BD4E-CB4CCA059FC4}" type="datetimeFigureOut">
               <a:rPr lang="en-US" smtClean="0"/>
-              <a:t>1/27/13</a:t>
+              <a:t>10/20/2026</a:t>
             </a:fld>
             <a:endParaRPr lang="en-US"/>
           </a:p>
@@ -927,10 +935,9 @@
           </a:lstStyle>
           <a:p>
             <a:r>
-              <a:rPr lang="en-US" smtClean="0"/>
+              <a:rPr lang="en-US"/>
               <a:t>Click to edit Master title style</a:t>
             </a:r>
-            <a:endParaRPr lang="en-US"/>
           </a:p>
         </p:txBody>
       </p:sp>
@@ -1047,7 +1054,7 @@
           <a:p>
             <a:pPr lvl="0"/>
             <a:r>
-              <a:rPr lang="en-US" smtClean="0"/>
+              <a:rPr lang="en-US"/>
               <a:t>Click to edit Master text styles</a:t>
             </a:r>
           </a:p>
@@ -1070,7 +1077,7 @@
           <a:p>
             <a:fld id="{5BCAD085-E8A6-8845-BD4E-CB4CCA059FC4}" type="datetimeFigureOut">
               <a:rPr lang="en-US" smtClean="0"/>
-              <a:t>1/27/13</a:t>
+              <a:t>10/20/2026</a:t>
             </a:fld>
             <a:endParaRPr lang="en-US"/>
           </a:p>
@@ -1164,10 +1171,9 @@
           <a:lstStyle/>
           <a:p>
             <a:r>
-              <a:rPr lang="en-US" smtClean="0"/>
+              <a:rPr lang="en-US"/>
               <a:t>Click to edit Master title style</a:t>
             </a:r>
-            <a:endParaRPr lang="en-US"/>
           </a:p>
         </p:txBody>
       </p:sp>
@@ -1221,38 +1227,37 @@
           <a:p>
             <a:pPr lvl="0"/>
             <a:r>
-              <a:rPr lang="en-US" smtClean="0"/>
+              <a:rPr lang="en-US"/>
               <a:t>Click to edit Master text styles</a:t>
             </a:r>
           </a:p>
           <a:p>
             <a:pPr lvl="1"/>
             <a:r>
-              <a:rPr lang="en-US" smtClean="0"/>
+              <a:rPr lang="en-US"/>
               <a:t>Second level</a:t>
             </a:r>
           </a:p>
           <a:p>
             <a:pPr lvl="2"/>
             <a:r>
-              <a:rPr lang="en-US" smtClean="0"/>
+              <a:rPr lang="en-US"/>
               <a:t>Third level</a:t>
             </a:r>
           </a:p>
           <a:p>
             <a:pPr lvl="3"/>
             <a:r>
-              <a:rPr lang="en-US" smtClean="0"/>
+              <a:rPr lang="en-US"/>
               <a:t>Fourth level</a:t>
             </a:r>
           </a:p>
           <a:p>
             <a:pPr lvl="4"/>
             <a:r>
-              <a:rPr lang="en-US" smtClean="0"/>
+              <a:rPr lang="en-US"/>
               <a:t>Fifth level</a:t>
             </a:r>
-            <a:endParaRPr lang="en-US"/>
           </a:p>
         </p:txBody>
       </p:sp>
@@ -1306,38 +1311,37 @@
           <a:p>
             <a:pPr lvl="0"/>
             <a:r>
-              <a:rPr lang="en-US" smtClean="0"/>
+              <a:rPr lang="en-US"/>
               <a:t>Click to edit Master text styles</a:t>
             </a:r>
           </a:p>
           <a:p>
             <a:pPr lvl="1"/>
             <a:r>
-              <a:rPr lang="en-US" smtClean="0"/>
+              <a:rPr lang="en-US"/>
               <a:t>Second level</a:t>
             </a:r>
           </a:p>
           <a:p>
             <a:pPr lvl="2"/>
             <a:r>
-              <a:rPr lang="en-US" smtClean="0"/>
+              <a:rPr lang="en-US"/>
               <a:t>Third level</a:t>
             </a:r>
           </a:p>
           <a:p>
             <a:pPr lvl="3"/>
             <a:r>
-              <a:rPr lang="en-US" smtClean="0"/>
+              <a:rPr lang="en-US"/>
               <a:t>Fourth level</a:t>
             </a:r>
           </a:p>
           <a:p>
             <a:pPr lvl="4"/>
             <a:r>
-              <a:rPr lang="en-US" smtClean="0"/>
+              <a:rPr lang="en-US"/>
               <a:t>Fifth level</a:t>
             </a:r>
-            <a:endParaRPr lang="en-US"/>
           </a:p>
         </p:txBody>
       </p:sp>
@@ -1358,7 +1362,7 @@
           <a:p>
             <a:fld id="{5BCAD085-E8A6-8845-BD4E-CB4CCA059FC4}" type="datetimeFigureOut">
               <a:rPr lang="en-US" smtClean="0"/>
-              <a:t>1/27/13</a:t>
+              <a:t>10/20/2026</a:t>
             </a:fld>
             <a:endParaRPr lang="en-US"/>
           </a:p>
@@ -1456,10 +1460,9 @@
           </a:lstStyle>
           <a:p>
             <a:r>
-              <a:rPr lang="en-US" smtClean="0"/>
+              <a:rPr lang="en-US"/>
               <a:t>Click to edit Master title style</a:t>
             </a:r>
-            <a:endParaRPr lang="en-US"/>
           </a:p>
         </p:txBody>
       </p:sp>
@@ -1522,7 +1525,7 @@
           <a:p>
             <a:pPr lvl="0"/>
             <a:r>
-              <a:rPr lang="en-US" smtClean="0"/>
+              <a:rPr lang="en-US"/>
               <a:t>Click to edit Master text styles</a:t>
             </a:r>
           </a:p>
@@ -1578,38 +1581,37 @@
           <a:p>
             <a:pPr lvl="0"/>
             <a:r>
-              <a:rPr lang="en-US" smtClean="0"/>
+              <a:rPr lang="en-US"/>
               <a:t>Click to edit Master text styles</a:t>
             </a:r>
           </a:p>
           <a:p>
             <a:pPr lvl="1"/>
             <a:r>
-              <a:rPr lang="en-US" smtClean="0"/>
+              <a:rPr lang="en-US"/>
               <a:t>Second level</a:t>
             </a:r>
           </a:p>
           <a:p>
             <a:pPr lvl="2"/>
             <a:r>
-              <a:rPr lang="en-US" smtClean="0"/>
+              <a:rPr lang="en-US"/>
               <a:t>Third level</a:t>
             </a:r>
           </a:p>
           <a:p>
             <a:pPr lvl="3"/>
             <a:r>
-              <a:rPr lang="en-US" smtClean="0"/>
+              <a:rPr lang="en-US"/>
               <a:t>Fourth level</a:t>
             </a:r>
           </a:p>
           <a:p>
             <a:pPr lvl="4"/>
             <a:r>
-              <a:rPr lang="en-US" smtClean="0"/>
+              <a:rPr lang="en-US"/>
               <a:t>Fifth level</a:t>
             </a:r>
-            <a:endParaRPr lang="en-US"/>
           </a:p>
         </p:txBody>
       </p:sp>
@@ -1672,7 +1674,7 @@
           <a:p>
             <a:pPr lvl="0"/>
             <a:r>
-              <a:rPr lang="en-US" smtClean="0"/>
+              <a:rPr lang="en-US"/>
               <a:t>Click to edit Master text styles</a:t>
             </a:r>
           </a:p>
@@ -1728,38 +1730,37 @@
           <a:p>
             <a:pPr lvl="0"/>
             <a:r>
-              <a:rPr lang="en-US" smtClean="0"/>
+              <a:rPr lang="en-US"/>
               <a:t>Click to edit Master text styles</a:t>
             </a:r>
           </a:p>
           <a:p>
             <a:pPr lvl="1"/>
             <a:r>
-              <a:rPr lang="en-US" smtClean="0"/>
+              <a:rPr lang="en-US"/>
               <a:t>Second level</a:t>
             </a:r>
           </a:p>
           <a:p>
             <a:pPr lvl="2"/>
             <a:r>
-              <a:rPr lang="en-US" smtClean="0"/>
+              <a:rPr lang="en-US"/>
               <a:t>Third level</a:t>
             </a:r>
           </a:p>
           <a:p>
             <a:pPr lvl="3"/>
             <a:r>
-              <a:rPr lang="en-US" smtClean="0"/>
+              <a:rPr lang="en-US"/>
               <a:t>Fourth level</a:t>
             </a:r>
           </a:p>
           <a:p>
             <a:pPr lvl="4"/>
             <a:r>
-              <a:rPr lang="en-US" smtClean="0"/>
+              <a:rPr lang="en-US"/>
               <a:t>Fifth level</a:t>
             </a:r>
-            <a:endParaRPr lang="en-US"/>
           </a:p>
         </p:txBody>
       </p:sp>
@@ -1780,7 +1781,7 @@
           <a:p>
             <a:fld id="{5BCAD085-E8A6-8845-BD4E-CB4CCA059FC4}" type="datetimeFigureOut">
               <a:rPr lang="en-US" smtClean="0"/>
-              <a:t>1/27/13</a:t>
+              <a:t>10/20/2026</a:t>
             </a:fld>
             <a:endParaRPr lang="en-US"/>
           </a:p>
@@ -1874,10 +1875,9 @@
           <a:lstStyle/>
           <a:p>
             <a:r>
-              <a:rPr lang="en-US" smtClean="0"/>
+              <a:rPr lang="en-US"/>
               <a:t>Click to edit Master title style</a:t>
             </a:r>
-            <a:endParaRPr lang="en-US"/>
           </a:p>
         </p:txBody>
       </p:sp>
@@ -1898,7 +1898,7 @@
           <a:p>
             <a:fld id="{5BCAD085-E8A6-8845-BD4E-CB4CCA059FC4}" type="datetimeFigureOut">
               <a:rPr lang="en-US" smtClean="0"/>
-              <a:t>1/27/13</a:t>
+              <a:t>10/20/2026</a:t>
             </a:fld>
             <a:endParaRPr lang="en-US"/>
           </a:p>
@@ -1993,7 +1993,7 @@
           <a:p>
             <a:fld id="{5BCAD085-E8A6-8845-BD4E-CB4CCA059FC4}" type="datetimeFigureOut">
               <a:rPr lang="en-US" smtClean="0"/>
-              <a:t>1/27/13</a:t>
+              <a:t>10/20/2026</a:t>
             </a:fld>
             <a:endParaRPr lang="en-US"/>
           </a:p>
@@ -2096,10 +2096,9 @@
           </a:lstStyle>
           <a:p>
             <a:r>
-              <a:rPr lang="en-US" smtClean="0"/>
+              <a:rPr lang="en-US"/>
               <a:t>Click to edit Master title style</a:t>
             </a:r>
-            <a:endParaRPr lang="en-US"/>
           </a:p>
         </p:txBody>
       </p:sp>
@@ -2153,38 +2152,37 @@
           <a:p>
             <a:pPr lvl="0"/>
             <a:r>
-              <a:rPr lang="en-US" smtClean="0"/>
+              <a:rPr lang="en-US"/>
               <a:t>Click to edit Master text styles</a:t>
             </a:r>
           </a:p>
           <a:p>
             <a:pPr lvl="1"/>
             <a:r>
-              <a:rPr lang="en-US" smtClean="0"/>
+              <a:rPr lang="en-US"/>
               <a:t>Second level</a:t>
             </a:r>
           </a:p>
           <a:p>
             <a:pPr lvl="2"/>
             <a:r>
-              <a:rPr lang="en-US" smtClean="0"/>
+              <a:rPr lang="en-US"/>
               <a:t>Third level</a:t>
             </a:r>
           </a:p>
           <a:p>
             <a:pPr lvl="3"/>
             <a:r>
-              <a:rPr lang="en-US" smtClean="0"/>
+              <a:rPr lang="en-US"/>
               <a:t>Fourth level</a:t>
             </a:r>
           </a:p>
           <a:p>
             <a:pPr lvl="4"/>
             <a:r>
-              <a:rPr lang="en-US" smtClean="0"/>
+              <a:rPr lang="en-US"/>
               <a:t>Fifth level</a:t>
             </a:r>
-            <a:endParaRPr lang="en-US"/>
           </a:p>
         </p:txBody>
       </p:sp>
@@ -2247,7 +2245,7 @@
           <a:p>
             <a:pPr lvl="0"/>
             <a:r>
-              <a:rPr lang="en-US" smtClean="0"/>
+              <a:rPr lang="en-US"/>
               <a:t>Click to edit Master text styles</a:t>
             </a:r>
           </a:p>
@@ -2270,7 +2268,7 @@
           <a:p>
             <a:fld id="{5BCAD085-E8A6-8845-BD4E-CB4CCA059FC4}" type="datetimeFigureOut">
               <a:rPr lang="en-US" smtClean="0"/>
-              <a:t>1/27/13</a:t>
+              <a:t>10/20/2026</a:t>
             </a:fld>
             <a:endParaRPr lang="en-US"/>
           </a:p>
@@ -2373,10 +2371,9 @@
           </a:lstStyle>
           <a:p>
             <a:r>
-              <a:rPr lang="en-US" smtClean="0"/>
+              <a:rPr lang="en-US"/>
               <a:t>Click to edit Master title style</a:t>
             </a:r>
-            <a:endParaRPr lang="en-US"/>
           </a:p>
         </p:txBody>
       </p:sp>
@@ -2500,7 +2497,7 @@
           <a:p>
             <a:pPr lvl="0"/>
             <a:r>
-              <a:rPr lang="en-US" smtClean="0"/>
+              <a:rPr lang="en-US"/>
               <a:t>Click to edit Master text styles</a:t>
             </a:r>
           </a:p>
@@ -2523,7 +2520,7 @@
           <a:p>
             <a:fld id="{5BCAD085-E8A6-8845-BD4E-CB4CCA059FC4}" type="datetimeFigureOut">
               <a:rPr lang="en-US" smtClean="0"/>
-              <a:t>1/27/13</a:t>
+              <a:t>10/20/2026</a:t>
             </a:fld>
             <a:endParaRPr lang="en-US"/>
           </a:p>
@@ -2632,10 +2629,9 @@
           <a:lstStyle/>
           <a:p>
             <a:r>
-              <a:rPr lang="en-US" smtClean="0"/>
+              <a:rPr lang="en-US"/>
               <a:t>Click to edit Master title style</a:t>
             </a:r>
-            <a:endParaRPr lang="en-US"/>
           </a:p>
         </p:txBody>
       </p:sp>
@@ -2666,38 +2662,37 @@
           <a:p>
             <a:pPr lvl="0"/>
             <a:r>
-              <a:rPr lang="en-US" smtClean="0"/>
+              <a:rPr lang="en-US"/>
               <a:t>Click to edit Master text styles</a:t>
             </a:r>
           </a:p>
           <a:p>
             <a:pPr lvl="1"/>
             <a:r>
-              <a:rPr lang="en-US" smtClean="0"/>
+              <a:rPr lang="en-US"/>
               <a:t>Second level</a:t>
             </a:r>
           </a:p>
           <a:p>
             <a:pPr lvl="2"/>
             <a:r>
-              <a:rPr lang="en-US" smtClean="0"/>
+              <a:rPr lang="en-US"/>
               <a:t>Third level</a:t>
             </a:r>
           </a:p>
           <a:p>
             <a:pPr lvl="3"/>
             <a:r>
-              <a:rPr lang="en-US" smtClean="0"/>
+              <a:rPr lang="en-US"/>
               <a:t>Fourth level</a:t>
             </a:r>
           </a:p>
           <a:p>
             <a:pPr lvl="4"/>
             <a:r>
-              <a:rPr lang="en-US" smtClean="0"/>
+              <a:rPr lang="en-US"/>
               <a:t>Fifth level</a:t>
             </a:r>
-            <a:endParaRPr lang="en-US"/>
           </a:p>
         </p:txBody>
       </p:sp>
@@ -2736,7 +2731,7 @@
           <a:p>
             <a:fld id="{5BCAD085-E8A6-8845-BD4E-CB4CCA059FC4}" type="datetimeFigureOut">
               <a:rPr lang="en-US" smtClean="0"/>
-              <a:t>1/27/13</a:t>
+              <a:t>10/20/2026</a:t>
             </a:fld>
             <a:endParaRPr lang="en-US"/>
           </a:p>
@@ -3095,7 +3090,7 @@
 </file>
 
 <file path=ppt/slides/slide1.xml><?xml version="1.0" encoding="utf-8"?>
-<p:sld xmlns:a="http://schemas.openxmlformats.org/drawingml/2006/main" xmlns:p="http://schemas.openxmlformats.org/presentationml/2006/main" xmlns:r="http://schemas.openxmlformats.org/officeDocument/2006/relationships">
+<p:sld xmlns:a="http://schemas.openxmlformats.org/drawingml/2006/main" xmlns:r="http://schemas.openxmlformats.org/officeDocument/2006/relationships" xmlns:p="http://schemas.openxmlformats.org/presentationml/2006/main">
   <p:cSld>
     <p:spTree>
       <p:nvGrpSpPr>
@@ -3103,7 +3098,14 @@
         <p:cNvGrpSpPr/>
         <p:nvPr/>
       </p:nvGrpSpPr>
-      <p:grpSpPr/>
+      <p:grpSpPr>
+        <a:xfrm>
+          <a:off x="0" y="0"/>
+          <a:ext cx="0" cy="0"/>
+          <a:chOff x="0" y="0"/>
+          <a:chExt cx="0" cy="0"/>
+        </a:xfrm>
+      </p:grpSpPr>
       <p:sp>
         <p:nvSpPr>
           <p:cNvPr id="2" name="Rectangle 1"/>
@@ -3144,6 +3146,7 @@
           <a:lstStyle/>
           <a:p>
             <a:pPr algn="ctr"/>
+            <a:endParaRPr/>
           </a:p>
         </p:txBody>
       </p:sp>
@@ -3229,7 +3232,16 @@
               </a:defRPr>
             </a:pPr>
             <a:r>
-              <a:t>Online Quiz System (QuizSphere Pro)</a:t>
+              <a:rPr dirty="0"/>
+              <a:t>Online Quiz System (</a:t>
+            </a:r>
+            <a:r>
+              <a:rPr dirty="0" err="1"/>
+              <a:t>QuizSphere</a:t>
+            </a:r>
+            <a:r>
+              <a:rPr dirty="0"/>
+              <a:t> Pro)</a:t>
             </a:r>
           </a:p>
           <a:p>
@@ -3244,6 +3256,7 @@
               </a:defRPr>
             </a:pPr>
             <a:r>
+              <a:rPr dirty="0"/>
               <a:t>Process Map, Stakeholders, Measurable Requirements &amp; System Architecture</a:t>
             </a:r>
           </a:p>
@@ -3291,6 +3304,7 @@
           <a:lstStyle/>
           <a:p>
             <a:pPr algn="ctr"/>
+            <a:endParaRPr/>
           </a:p>
         </p:txBody>
       </p:sp>
@@ -3334,6 +3348,7 @@
           <a:lstStyle/>
           <a:p>
             <a:pPr algn="ctr"/>
+            <a:endParaRPr/>
           </a:p>
         </p:txBody>
       </p:sp>
@@ -3433,6 +3448,7 @@
           <a:lstStyle/>
           <a:p>
             <a:pPr algn="ctr"/>
+            <a:endParaRPr/>
           </a:p>
         </p:txBody>
       </p:sp>
@@ -3476,6 +3492,7 @@
           <a:lstStyle/>
           <a:p>
             <a:pPr algn="ctr"/>
+            <a:endParaRPr/>
           </a:p>
         </p:txBody>
       </p:sp>
@@ -3575,6 +3592,7 @@
           <a:lstStyle/>
           <a:p>
             <a:pPr algn="ctr"/>
+            <a:endParaRPr/>
           </a:p>
         </p:txBody>
       </p:sp>
@@ -3618,6 +3636,7 @@
           <a:lstStyle/>
           <a:p>
             <a:pPr algn="ctr"/>
+            <a:endParaRPr/>
           </a:p>
         </p:txBody>
       </p:sp>
@@ -3717,6 +3736,7 @@
           <a:lstStyle/>
           <a:p>
             <a:pPr algn="ctr"/>
+            <a:endParaRPr/>
           </a:p>
         </p:txBody>
       </p:sp>
@@ -3760,6 +3780,7 @@
           <a:lstStyle/>
           <a:p>
             <a:pPr algn="ctr"/>
+            <a:endParaRPr/>
           </a:p>
         </p:txBody>
       </p:sp>
@@ -3826,7 +3847,7 @@
 </file>
 
 <file path=ppt/slides/slide10.xml><?xml version="1.0" encoding="utf-8"?>
-<p:sld xmlns:a="http://schemas.openxmlformats.org/drawingml/2006/main" xmlns:p="http://schemas.openxmlformats.org/presentationml/2006/main" xmlns:r="http://schemas.openxmlformats.org/officeDocument/2006/relationships">
+<p:sld xmlns:a="http://schemas.openxmlformats.org/drawingml/2006/main" xmlns:r="http://schemas.openxmlformats.org/officeDocument/2006/relationships" xmlns:p="http://schemas.openxmlformats.org/presentationml/2006/main">
   <p:cSld>
     <p:spTree>
       <p:nvGrpSpPr>
@@ -3834,7 +3855,14 @@
         <p:cNvGrpSpPr/>
         <p:nvPr/>
       </p:nvGrpSpPr>
-      <p:grpSpPr/>
+      <p:grpSpPr>
+        <a:xfrm>
+          <a:off x="0" y="0"/>
+          <a:ext cx="0" cy="0"/>
+          <a:chOff x="0" y="0"/>
+          <a:chExt cx="0" cy="0"/>
+        </a:xfrm>
+      </p:grpSpPr>
       <p:sp>
         <p:nvSpPr>
           <p:cNvPr id="2" name="Rectangle 1"/>
@@ -3875,6 +3903,7 @@
           <a:lstStyle/>
           <a:p>
             <a:pPr algn="ctr"/>
+            <a:endParaRPr/>
           </a:p>
         </p:txBody>
       </p:sp>
@@ -3943,6 +3972,7 @@
               </a:defRPr>
             </a:pPr>
             <a:r>
+              <a:rPr dirty="0"/>
               <a:t>Database &amp; System Design (ACID SQLite Persistence)</a:t>
             </a:r>
           </a:p>
@@ -4025,6 +4055,7 @@
           <a:lstStyle/>
           <a:p>
             <a:pPr algn="ctr"/>
+            <a:endParaRPr/>
           </a:p>
         </p:txBody>
       </p:sp>
@@ -4068,6 +4099,7 @@
           <a:lstStyle/>
           <a:p>
             <a:pPr algn="ctr"/>
+            <a:endParaRPr/>
           </a:p>
         </p:txBody>
       </p:sp>
@@ -4079,7 +4111,7 @@
         </p:nvSpPr>
         <p:spPr>
           <a:xfrm>
-            <a:off x="914400" y="1783080"/>
+            <a:off x="370936" y="1856232"/>
             <a:ext cx="5852160" cy="1097280"/>
           </a:xfrm>
           <a:prstGeom prst="rect">
@@ -4104,6 +4136,7 @@
               </a:defRPr>
             </a:pPr>
             <a:r>
+              <a:rPr dirty="0"/>
               <a:t>TABLE: users</a:t>
             </a:r>
           </a:p>
@@ -4116,8 +4149,30 @@
               </a:defRPr>
             </a:pPr>
             <a:r>
-              <a:t>id (PK), username (UNIQUE), password_hash, role, full_name, department, created_at</a:t>
-            </a:r>
+              <a:rPr dirty="0"/>
+              <a:t>id (PK), username (UNIQUE), </a:t>
+            </a:r>
+            <a:r>
+              <a:rPr dirty="0" err="1"/>
+              <a:t>password_hash</a:t>
+            </a:r>
+            <a:r>
+              <a:rPr dirty="0"/>
+              <a:t>, role, </a:t>
+            </a:r>
+            <a:r>
+              <a:rPr dirty="0" err="1"/>
+              <a:t>full_name</a:t>
+            </a:r>
+            <a:r>
+              <a:rPr dirty="0"/>
+              <a:t>, department, </a:t>
+            </a:r>
+            <a:r>
+              <a:rPr dirty="0" err="1"/>
+              <a:t>created_at</a:t>
+            </a:r>
+            <a:endParaRPr dirty="0"/>
           </a:p>
         </p:txBody>
       </p:sp>
@@ -4163,6 +4218,7 @@
           <a:lstStyle/>
           <a:p>
             <a:pPr algn="ctr"/>
+            <a:endParaRPr/>
           </a:p>
         </p:txBody>
       </p:sp>
@@ -4206,6 +4262,7 @@
           <a:lstStyle/>
           <a:p>
             <a:pPr algn="ctr"/>
+            <a:endParaRPr/>
           </a:p>
         </p:txBody>
       </p:sp>
@@ -4242,6 +4299,7 @@
               </a:defRPr>
             </a:pPr>
             <a:r>
+              <a:rPr dirty="0"/>
               <a:t>TABLE: quizzes</a:t>
             </a:r>
           </a:p>
@@ -4254,8 +4312,38 @@
               </a:defRPr>
             </a:pPr>
             <a:r>
-              <a:t>id (PK), join_code (UNIQUE), teacher_name, title, category, duration, passing_score, questions_json</a:t>
-            </a:r>
+              <a:rPr lang="en-IN" dirty="0"/>
+              <a:t>id (PK), </a:t>
+            </a:r>
+            <a:r>
+              <a:rPr lang="en-IN" dirty="0" err="1"/>
+              <a:t>join_code</a:t>
+            </a:r>
+            <a:r>
+              <a:rPr lang="en-IN" dirty="0"/>
+              <a:t> (UNIQUE), </a:t>
+            </a:r>
+            <a:r>
+              <a:rPr lang="en-IN" dirty="0" err="1"/>
+              <a:t>teacher_name</a:t>
+            </a:r>
+            <a:r>
+              <a:rPr lang="en-IN" dirty="0"/>
+              <a:t>, title, category, duration, </a:t>
+            </a:r>
+            <a:r>
+              <a:rPr lang="en-IN" dirty="0" err="1"/>
+              <a:t>passing_score</a:t>
+            </a:r>
+            <a:r>
+              <a:rPr lang="en-IN" dirty="0"/>
+              <a:t>, </a:t>
+            </a:r>
+            <a:r>
+              <a:rPr lang="en-IN" dirty="0" err="1"/>
+              <a:t>questions_json</a:t>
+            </a:r>
+            <a:endParaRPr dirty="0"/>
           </a:p>
         </p:txBody>
       </p:sp>
@@ -4301,6 +4389,7 @@
           <a:lstStyle/>
           <a:p>
             <a:pPr algn="ctr"/>
+            <a:endParaRPr/>
           </a:p>
         </p:txBody>
       </p:sp>
@@ -4344,6 +4433,7 @@
           <a:lstStyle/>
           <a:p>
             <a:pPr algn="ctr"/>
+            <a:endParaRPr/>
           </a:p>
         </p:txBody>
       </p:sp>
@@ -4380,6 +4470,7 @@
               </a:defRPr>
             </a:pPr>
             <a:r>
+              <a:rPr dirty="0"/>
               <a:t>TABLE: attempts</a:t>
             </a:r>
           </a:p>
@@ -4392,8 +4483,46 @@
               </a:defRPr>
             </a:pPr>
             <a:r>
-              <a:t>id (PK), quiz_id (FK), join_code, student_name, score, percentage, passed, cheat_violations, submitted_at</a:t>
-            </a:r>
+              <a:rPr dirty="0"/>
+              <a:t>id (PK), </a:t>
+            </a:r>
+            <a:r>
+              <a:rPr dirty="0" err="1"/>
+              <a:t>quiz_id</a:t>
+            </a:r>
+            <a:r>
+              <a:rPr dirty="0"/>
+              <a:t> (FK), </a:t>
+            </a:r>
+            <a:r>
+              <a:rPr dirty="0" err="1"/>
+              <a:t>join_code</a:t>
+            </a:r>
+            <a:r>
+              <a:rPr dirty="0"/>
+              <a:t>, </a:t>
+            </a:r>
+            <a:r>
+              <a:rPr dirty="0" err="1"/>
+              <a:t>student_name</a:t>
+            </a:r>
+            <a:r>
+              <a:rPr dirty="0"/>
+              <a:t>, score, percentage, passed, </a:t>
+            </a:r>
+            <a:r>
+              <a:rPr dirty="0" err="1"/>
+              <a:t>cheat_violations</a:t>
+            </a:r>
+            <a:r>
+              <a:rPr dirty="0"/>
+              <a:t>, </a:t>
+            </a:r>
+            <a:r>
+              <a:rPr dirty="0" err="1"/>
+              <a:t>submitted_at</a:t>
+            </a:r>
+            <a:endParaRPr dirty="0"/>
           </a:p>
         </p:txBody>
       </p:sp>
@@ -4439,6 +4568,7 @@
           <a:lstStyle/>
           <a:p>
             <a:pPr algn="ctr"/>
+            <a:endParaRPr/>
           </a:p>
         </p:txBody>
       </p:sp>
@@ -4482,6 +4612,7 @@
           <a:lstStyle/>
           <a:p>
             <a:pPr algn="ctr"/>
+            <a:endParaRPr/>
           </a:p>
         </p:txBody>
       </p:sp>
@@ -4518,6 +4649,7 @@
               </a:defRPr>
             </a:pPr>
             <a:r>
+              <a:rPr dirty="0"/>
               <a:t>INTEGRITY &amp; MIGRATION HIGHLIGHTS</a:t>
             </a:r>
           </a:p>
@@ -4533,6 +4665,7 @@
               </a:defRPr>
             </a:pPr>
             <a:r>
+              <a:rPr dirty="0"/>
               <a:t>• ACID Transactions:</a:t>
             </a:r>
           </a:p>
@@ -4545,6 +4678,7 @@
               </a:defRPr>
             </a:pPr>
             <a:r>
+              <a:rPr dirty="0"/>
               <a:t>  All test submissions execute in atomic write transactions; zero partial attempts.</a:t>
             </a:r>
           </a:p>
@@ -4560,6 +4694,7 @@
               </a:defRPr>
             </a:pPr>
             <a:r>
+              <a:rPr dirty="0"/>
               <a:t>• Indexed Lookups:</a:t>
             </a:r>
           </a:p>
@@ -4572,6 +4707,7 @@
               </a:defRPr>
             </a:pPr>
             <a:r>
+              <a:rPr dirty="0"/>
               <a:t>  Uppercase indexed Join Codes ensure &lt;25ms question retrieval.</a:t>
             </a:r>
           </a:p>
@@ -4587,6 +4723,7 @@
               </a:defRPr>
             </a:pPr>
             <a:r>
+              <a:rPr dirty="0"/>
               <a:t>• Immutable Snapshots:</a:t>
             </a:r>
           </a:p>
@@ -4599,6 +4736,7 @@
               </a:defRPr>
             </a:pPr>
             <a:r>
+              <a:rPr dirty="0"/>
               <a:t>  Questions serialized as self-contained JSON strings inside quizzes to prevent drift.</a:t>
             </a:r>
           </a:p>
@@ -4614,6 +4752,7 @@
               </a:defRPr>
             </a:pPr>
             <a:r>
+              <a:rPr dirty="0"/>
               <a:t>• Why migrations.py matters:</a:t>
             </a:r>
           </a:p>
@@ -4626,7 +4765,24 @@
               </a:defRPr>
             </a:pPr>
             <a:r>
-              <a:t>  Adds new columns (e.g. join_code, cheat_violations) to live files without wiping student test records.</a:t>
+              <a:rPr dirty="0"/>
+              <a:t>  Adds new columns (e.g. </a:t>
+            </a:r>
+            <a:r>
+              <a:rPr dirty="0" err="1"/>
+              <a:t>join_code</a:t>
+            </a:r>
+            <a:r>
+              <a:rPr dirty="0"/>
+              <a:t>, </a:t>
+            </a:r>
+            <a:r>
+              <a:rPr dirty="0" err="1"/>
+              <a:t>cheat_violations</a:t>
+            </a:r>
+            <a:r>
+              <a:rPr dirty="0"/>
+              <a:t>) to live files without wiping student test records.</a:t>
             </a:r>
           </a:p>
         </p:txBody>
@@ -4640,7 +4796,7 @@
 </file>
 
 <file path=ppt/slides/slide11.xml><?xml version="1.0" encoding="utf-8"?>
-<p:sld xmlns:a="http://schemas.openxmlformats.org/drawingml/2006/main" xmlns:p="http://schemas.openxmlformats.org/presentationml/2006/main" xmlns:r="http://schemas.openxmlformats.org/officeDocument/2006/relationships">
+<p:sld xmlns:a="http://schemas.openxmlformats.org/drawingml/2006/main" xmlns:r="http://schemas.openxmlformats.org/officeDocument/2006/relationships" xmlns:p="http://schemas.openxmlformats.org/presentationml/2006/main">
   <p:cSld>
     <p:spTree>
       <p:nvGrpSpPr>
@@ -4648,7 +4804,14 @@
         <p:cNvGrpSpPr/>
         <p:nvPr/>
       </p:nvGrpSpPr>
-      <p:grpSpPr/>
+      <p:grpSpPr>
+        <a:xfrm>
+          <a:off x="0" y="0"/>
+          <a:ext cx="0" cy="0"/>
+          <a:chOff x="0" y="0"/>
+          <a:chExt cx="0" cy="0"/>
+        </a:xfrm>
+      </p:grpSpPr>
       <p:sp>
         <p:nvSpPr>
           <p:cNvPr id="2" name="Rectangle 1"/>
@@ -4689,6 +4852,7 @@
           <a:lstStyle/>
           <a:p>
             <a:pPr algn="ctr"/>
+            <a:endParaRPr/>
           </a:p>
         </p:txBody>
       </p:sp>
@@ -4757,6 +4921,7 @@
               </a:defRPr>
             </a:pPr>
             <a:r>
+              <a:rPr dirty="0"/>
               <a:t>CRUD Operations Aligned with Quality Goals</a:t>
             </a:r>
           </a:p>
@@ -4839,6 +5004,7 @@
           <a:lstStyle/>
           <a:p>
             <a:pPr algn="ctr"/>
+            <a:endParaRPr/>
           </a:p>
         </p:txBody>
       </p:sp>
@@ -4882,6 +5048,7 @@
           <a:lstStyle/>
           <a:p>
             <a:pPr algn="ctr"/>
+            <a:endParaRPr/>
           </a:p>
         </p:txBody>
       </p:sp>
@@ -4918,6 +5085,7 @@
               </a:defRPr>
             </a:pPr>
             <a:r>
+              <a:rPr dirty="0"/>
               <a:t>USER MANAGEMENT</a:t>
             </a:r>
           </a:p>
@@ -4933,7 +5101,16 @@
               </a:defRPr>
             </a:pPr>
             <a:r>
-              <a:t>• CREATE: Register accounts via /api/auth/register or Desktop UI</a:t>
+              <a:rPr dirty="0"/>
+              <a:t>• CREATE: Register accounts via /</a:t>
+            </a:r>
+            <a:r>
+              <a:rPr dirty="0" err="1"/>
+              <a:t>api</a:t>
+            </a:r>
+            <a:r>
+              <a:rPr dirty="0"/>
+              <a:t>/auth/register or Desktop UI</a:t>
             </a:r>
           </a:p>
           <a:p>
@@ -4948,7 +5125,24 @@
               </a:defRPr>
             </a:pPr>
             <a:r>
-              <a:t>• READ: Authenticate (/api/auth/login), Roster (/api/admin/users)</a:t>
+              <a:rPr dirty="0"/>
+              <a:t>• READ: Authenticate (/</a:t>
+            </a:r>
+            <a:r>
+              <a:rPr dirty="0" err="1"/>
+              <a:t>api</a:t>
+            </a:r>
+            <a:r>
+              <a:rPr dirty="0"/>
+              <a:t>/auth/login), Roster (/</a:t>
+            </a:r>
+            <a:r>
+              <a:rPr dirty="0" err="1"/>
+              <a:t>api</a:t>
+            </a:r>
+            <a:r>
+              <a:rPr dirty="0"/>
+              <a:t>/admin/users)</a:t>
             </a:r>
           </a:p>
           <a:p>
@@ -4963,6 +5157,7 @@
               </a:defRPr>
             </a:pPr>
             <a:r>
+              <a:rPr dirty="0"/>
               <a:t>• UPDATE: Department assignment, accommodation time buffers</a:t>
             </a:r>
           </a:p>
@@ -4978,6 +5173,7 @@
               </a:defRPr>
             </a:pPr>
             <a:r>
+              <a:rPr dirty="0"/>
               <a:t>• DELETE: Soft-deactivate accounts and revoke active permissions</a:t>
             </a:r>
           </a:p>
@@ -5025,6 +5221,7 @@
           <a:lstStyle/>
           <a:p>
             <a:pPr algn="ctr"/>
+            <a:endParaRPr/>
           </a:p>
         </p:txBody>
       </p:sp>
@@ -5068,6 +5265,7 @@
           <a:lstStyle/>
           <a:p>
             <a:pPr algn="ctr"/>
+            <a:endParaRPr/>
           </a:p>
         </p:txBody>
       </p:sp>
@@ -5104,6 +5302,7 @@
               </a:defRPr>
             </a:pPr>
             <a:r>
+              <a:rPr dirty="0"/>
               <a:t>ASSESSMENT MANAGEMENT</a:t>
             </a:r>
           </a:p>
@@ -5119,7 +5318,24 @@
               </a:defRPr>
             </a:pPr>
             <a:r>
-              <a:t>• CREATE: Manual authoring (/api/quizzes) or AI Wizard (/api/ai-generate)</a:t>
+              <a:rPr dirty="0"/>
+              <a:t>• CREATE: Manual authoring (/</a:t>
+            </a:r>
+            <a:r>
+              <a:rPr dirty="0" err="1"/>
+              <a:t>api</a:t>
+            </a:r>
+            <a:r>
+              <a:rPr dirty="0"/>
+              <a:t>/quizzes) or AI Wizard (/</a:t>
+            </a:r>
+            <a:r>
+              <a:rPr dirty="0" err="1"/>
+              <a:t>api</a:t>
+            </a:r>
+            <a:r>
+              <a:rPr dirty="0"/>
+              <a:t>/ai-generate)</a:t>
             </a:r>
           </a:p>
           <a:p>
@@ -5134,7 +5350,16 @@
               </a:defRPr>
             </a:pPr>
             <a:r>
-              <a:t>• READ: Code resolver (/api/quizzes/code/{code}), Public test list</a:t>
+              <a:rPr dirty="0"/>
+              <a:t>• READ: Code resolver (/</a:t>
+            </a:r>
+            <a:r>
+              <a:rPr dirty="0" err="1"/>
+              <a:t>api</a:t>
+            </a:r>
+            <a:r>
+              <a:rPr dirty="0"/>
+              <a:t>/quizzes/code/{code}), Public test list</a:t>
             </a:r>
           </a:p>
           <a:p>
@@ -5149,6 +5374,7 @@
               </a:defRPr>
             </a:pPr>
             <a:r>
+              <a:rPr dirty="0"/>
               <a:t>• UPDATE: Modify time duration, passing mark, or question sets</a:t>
             </a:r>
           </a:p>
@@ -5164,6 +5390,7 @@
               </a:defRPr>
             </a:pPr>
             <a:r>
+              <a:rPr dirty="0"/>
               <a:t>• DELETE: Archive assessment and withdraw public Join Code</a:t>
             </a:r>
           </a:p>
@@ -5211,6 +5438,7 @@
           <a:lstStyle/>
           <a:p>
             <a:pPr algn="ctr"/>
+            <a:endParaRPr/>
           </a:p>
         </p:txBody>
       </p:sp>
@@ -5254,6 +5482,7 @@
           <a:lstStyle/>
           <a:p>
             <a:pPr algn="ctr"/>
+            <a:endParaRPr/>
           </a:p>
         </p:txBody>
       </p:sp>
@@ -5290,6 +5519,7 @@
               </a:defRPr>
             </a:pPr>
             <a:r>
+              <a:rPr dirty="0"/>
               <a:t>SUBMISSIONS &amp; AUDIT</a:t>
             </a:r>
           </a:p>
@@ -5305,7 +5535,16 @@
               </a:defRPr>
             </a:pPr>
             <a:r>
-              <a:t>• CREATE: Atomic test submission (/api/quizzes/{id}/submit)</a:t>
+              <a:rPr dirty="0"/>
+              <a:t>• CREATE: Atomic test submission (/</a:t>
+            </a:r>
+            <a:r>
+              <a:rPr dirty="0" err="1"/>
+              <a:t>api</a:t>
+            </a:r>
+            <a:r>
+              <a:rPr dirty="0"/>
+              <a:t>/quizzes/{id}/submit)</a:t>
             </a:r>
           </a:p>
           <a:p>
@@ -5320,7 +5559,16 @@
               </a:defRPr>
             </a:pPr>
             <a:r>
-              <a:t>• READ: Teacher Gradebook (/api/teacher/reports), Candidate Scorecards</a:t>
+              <a:rPr dirty="0"/>
+              <a:t>• READ: Teacher Gradebook (/</a:t>
+            </a:r>
+            <a:r>
+              <a:rPr dirty="0" err="1"/>
+              <a:t>api</a:t>
+            </a:r>
+            <a:r>
+              <a:rPr dirty="0"/>
+              <a:t>/teacher/reports), Candidate Scorecards</a:t>
             </a:r>
           </a:p>
           <a:p>
@@ -5335,6 +5583,7 @@
               </a:defRPr>
             </a:pPr>
             <a:r>
+              <a:rPr dirty="0"/>
               <a:t>• UPDATE: Durable autosave progress during active exam sessions</a:t>
             </a:r>
           </a:p>
@@ -5350,6 +5599,7 @@
               </a:defRPr>
             </a:pPr>
             <a:r>
+              <a:rPr dirty="0"/>
               <a:t>• DELETE: Controlled audit retention purge</a:t>
             </a:r>
           </a:p>
@@ -5397,6 +5647,7 @@
           <a:lstStyle/>
           <a:p>
             <a:pPr algn="ctr"/>
+            <a:endParaRPr/>
           </a:p>
         </p:txBody>
       </p:sp>
@@ -5440,6 +5691,7 @@
           <a:lstStyle/>
           <a:p>
             <a:pPr algn="ctr"/>
+            <a:endParaRPr/>
           </a:p>
         </p:txBody>
       </p:sp>
@@ -5476,6 +5728,7 @@
               </a:defRPr>
             </a:pPr>
             <a:r>
+              <a:rPr dirty="0"/>
               <a:t>BACKUPS &amp; REPORTS</a:t>
             </a:r>
           </a:p>
@@ -5491,6 +5744,7 @@
               </a:defRPr>
             </a:pPr>
             <a:r>
+              <a:rPr dirty="0"/>
               <a:t>• CREATE: Automated timestamped snapshots in backups/ directory</a:t>
             </a:r>
           </a:p>
@@ -5506,7 +5760,16 @@
               </a:defRPr>
             </a:pPr>
             <a:r>
-              <a:t>• READ: Stream CSV reports (/api/admin/export/users.csv &amp; submissions.csv)</a:t>
+              <a:rPr dirty="0"/>
+              <a:t>• READ: Stream CSV reports (/</a:t>
+            </a:r>
+            <a:r>
+              <a:rPr dirty="0" err="1"/>
+              <a:t>api</a:t>
+            </a:r>
+            <a:r>
+              <a:rPr dirty="0"/>
+              <a:t>/admin/export/users.csv &amp; submissions.csv)</a:t>
             </a:r>
           </a:p>
           <a:p>
@@ -5521,6 +5784,7 @@
               </a:defRPr>
             </a:pPr>
             <a:r>
+              <a:rPr dirty="0"/>
               <a:t>• UPDATE: Validate snapshot integrity against active database</a:t>
             </a:r>
           </a:p>
@@ -5536,6 +5800,7 @@
               </a:defRPr>
             </a:pPr>
             <a:r>
+              <a:rPr dirty="0"/>
               <a:t>• DELETE: Rolling backup policy purging snapshots older than 30 days</a:t>
             </a:r>
           </a:p>
@@ -5550,7 +5815,7 @@
 </file>
 
 <file path=ppt/slides/slide12.xml><?xml version="1.0" encoding="utf-8"?>
-<p:sld xmlns:a="http://schemas.openxmlformats.org/drawingml/2006/main" xmlns:p="http://schemas.openxmlformats.org/presentationml/2006/main" xmlns:r="http://schemas.openxmlformats.org/officeDocument/2006/relationships">
+<p:sld xmlns:a="http://schemas.openxmlformats.org/drawingml/2006/main" xmlns:r="http://schemas.openxmlformats.org/officeDocument/2006/relationships" xmlns:p="http://schemas.openxmlformats.org/presentationml/2006/main">
   <p:cSld>
     <p:spTree>
       <p:nvGrpSpPr>
@@ -5558,7 +5823,14 @@
         <p:cNvGrpSpPr/>
         <p:nvPr/>
       </p:nvGrpSpPr>
-      <p:grpSpPr/>
+      <p:grpSpPr>
+        <a:xfrm>
+          <a:off x="0" y="0"/>
+          <a:ext cx="0" cy="0"/>
+          <a:chOff x="0" y="0"/>
+          <a:chExt cx="0" cy="0"/>
+        </a:xfrm>
+      </p:grpSpPr>
       <p:sp>
         <p:nvSpPr>
           <p:cNvPr id="2" name="Rectangle 1"/>
@@ -5599,6 +5871,7 @@
           <a:lstStyle/>
           <a:p>
             <a:pPr algn="ctr"/>
+            <a:endParaRPr/>
           </a:p>
         </p:txBody>
       </p:sp>
@@ -5667,6 +5940,7 @@
               </a:defRPr>
             </a:pPr>
             <a:r>
+              <a:rPr dirty="0"/>
               <a:t>Initial UI &amp; System Workflow (How a Click Travels)</a:t>
             </a:r>
           </a:p>
@@ -5749,6 +6023,7 @@
           <a:lstStyle/>
           <a:p>
             <a:pPr algn="ctr"/>
+            <a:endParaRPr/>
           </a:p>
         </p:txBody>
       </p:sp>
@@ -5792,6 +6067,7 @@
           <a:lstStyle/>
           <a:p>
             <a:pPr algn="ctr"/>
+            <a:endParaRPr/>
           </a:p>
         </p:txBody>
       </p:sp>
@@ -5825,6 +6101,7 @@
               </a:defRPr>
             </a:pPr>
             <a:r>
+              <a:rPr dirty="0"/>
               <a:t>1. SCREEN</a:t>
             </a:r>
           </a:p>
@@ -5872,6 +6149,7 @@
           <a:lstStyle/>
           <a:p>
             <a:pPr algn="ctr"/>
+            <a:endParaRPr dirty="0"/>
           </a:p>
         </p:txBody>
       </p:sp>
@@ -5905,6 +6183,7 @@
               </a:defRPr>
             </a:pPr>
             <a:r>
+              <a:rPr dirty="0"/>
               <a:t>Candidate enters answers and clicks 'Submit Quiz' in Candidate Arena.</a:t>
             </a:r>
           </a:p>
@@ -5952,6 +6231,7 @@
           <a:lstStyle/>
           <a:p>
             <a:pPr algn="ctr"/>
+            <a:endParaRPr/>
           </a:p>
         </p:txBody>
       </p:sp>
@@ -5995,6 +6275,7 @@
           <a:lstStyle/>
           <a:p>
             <a:pPr algn="ctr"/>
+            <a:endParaRPr/>
           </a:p>
         </p:txBody>
       </p:sp>
@@ -6028,6 +6309,7 @@
               </a:defRPr>
             </a:pPr>
             <a:r>
+              <a:rPr dirty="0"/>
               <a:t>2. SERVICE</a:t>
             </a:r>
           </a:p>
@@ -6075,6 +6357,7 @@
           <a:lstStyle/>
           <a:p>
             <a:pPr algn="ctr"/>
+            <a:endParaRPr/>
           </a:p>
         </p:txBody>
       </p:sp>
@@ -6108,7 +6391,12 @@
               </a:defRPr>
             </a:pPr>
             <a:r>
-              <a:t>grading_service receives payload and matches answers against the key.</a:t>
+              <a:rPr dirty="0" err="1"/>
+              <a:t>grading_service</a:t>
+            </a:r>
+            <a:r>
+              <a:rPr dirty="0"/>
+              <a:t> receives payload and matches answers against the key.</a:t>
             </a:r>
           </a:p>
         </p:txBody>
@@ -6155,6 +6443,7 @@
           <a:lstStyle/>
           <a:p>
             <a:pPr algn="ctr"/>
+            <a:endParaRPr/>
           </a:p>
         </p:txBody>
       </p:sp>
@@ -6198,6 +6487,7 @@
           <a:lstStyle/>
           <a:p>
             <a:pPr algn="ctr"/>
+            <a:endParaRPr/>
           </a:p>
         </p:txBody>
       </p:sp>
@@ -6231,6 +6521,7 @@
               </a:defRPr>
             </a:pPr>
             <a:r>
+              <a:rPr dirty="0"/>
               <a:t>3. EXTRA SERVICE</a:t>
             </a:r>
           </a:p>
@@ -6278,6 +6569,7 @@
           <a:lstStyle/>
           <a:p>
             <a:pPr algn="ctr"/>
+            <a:endParaRPr/>
           </a:p>
         </p:txBody>
       </p:sp>
@@ -6311,7 +6603,12 @@
               </a:defRPr>
             </a:pPr>
             <a:r>
-              <a:t>proctor_service attaches violation counts and infraction timestamps.</a:t>
+              <a:rPr dirty="0" err="1"/>
+              <a:t>proctor_service</a:t>
+            </a:r>
+            <a:r>
+              <a:rPr dirty="0"/>
+              <a:t> attaches violation counts and infraction timestamps.</a:t>
             </a:r>
           </a:p>
         </p:txBody>
@@ -6358,6 +6655,7 @@
           <a:lstStyle/>
           <a:p>
             <a:pPr algn="ctr"/>
+            <a:endParaRPr/>
           </a:p>
         </p:txBody>
       </p:sp>
@@ -6401,6 +6699,7 @@
           <a:lstStyle/>
           <a:p>
             <a:pPr algn="ctr"/>
+            <a:endParaRPr/>
           </a:p>
         </p:txBody>
       </p:sp>
@@ -6434,6 +6733,7 @@
               </a:defRPr>
             </a:pPr>
             <a:r>
+              <a:rPr dirty="0"/>
               <a:t>4. UTILS</a:t>
             </a:r>
           </a:p>
@@ -6481,6 +6781,7 @@
           <a:lstStyle/>
           <a:p>
             <a:pPr algn="ctr"/>
+            <a:endParaRPr/>
           </a:p>
         </p:txBody>
       </p:sp>
@@ -6514,6 +6815,7 @@
               </a:defRPr>
             </a:pPr>
             <a:r>
+              <a:rPr dirty="0"/>
               <a:t>validators.py enforces schema bounds and rejects malformed payloads.</a:t>
             </a:r>
           </a:p>
@@ -6561,6 +6863,7 @@
           <a:lstStyle/>
           <a:p>
             <a:pPr algn="ctr"/>
+            <a:endParaRPr/>
           </a:p>
         </p:txBody>
       </p:sp>
@@ -6604,6 +6907,7 @@
           <a:lstStyle/>
           <a:p>
             <a:pPr algn="ctr"/>
+            <a:endParaRPr/>
           </a:p>
         </p:txBody>
       </p:sp>
@@ -6637,6 +6941,7 @@
               </a:defRPr>
             </a:pPr>
             <a:r>
+              <a:rPr dirty="0"/>
               <a:t>5. DATABASE</a:t>
             </a:r>
           </a:p>
@@ -6684,6 +6989,7 @@
           <a:lstStyle/>
           <a:p>
             <a:pPr algn="ctr"/>
+            <a:endParaRPr/>
           </a:p>
         </p:txBody>
       </p:sp>
@@ -6717,6 +7023,7 @@
               </a:defRPr>
             </a:pPr>
             <a:r>
+              <a:rPr dirty="0"/>
               <a:t>db.py executes atomic transaction saving attempt and violations in SQLite.</a:t>
             </a:r>
           </a:p>
@@ -6764,6 +7071,7 @@
           <a:lstStyle/>
           <a:p>
             <a:pPr algn="ctr"/>
+            <a:endParaRPr/>
           </a:p>
         </p:txBody>
       </p:sp>
@@ -6807,6 +7115,7 @@
           <a:lstStyle/>
           <a:p>
             <a:pPr algn="ctr"/>
+            <a:endParaRPr/>
           </a:p>
         </p:txBody>
       </p:sp>
@@ -6840,6 +7149,7 @@
               </a:defRPr>
             </a:pPr>
             <a:r>
+              <a:rPr dirty="0"/>
               <a:t>6. PROOF</a:t>
             </a:r>
           </a:p>
@@ -6887,6 +7197,7 @@
           <a:lstStyle/>
           <a:p>
             <a:pPr algn="ctr"/>
+            <a:endParaRPr/>
           </a:p>
         </p:txBody>
       </p:sp>
@@ -6920,7 +7231,12 @@
               </a:defRPr>
             </a:pPr>
             <a:r>
-              <a:t>audit_logs and attempts get a permanent row; Scorecard delivered in &lt;25ms.</a:t>
+              <a:rPr dirty="0" err="1"/>
+              <a:t>audit_logs</a:t>
+            </a:r>
+            <a:r>
+              <a:rPr dirty="0"/>
+              <a:t> and attempts get a permanent row; Scorecard delivered in &lt;25ms.</a:t>
             </a:r>
           </a:p>
         </p:txBody>
@@ -6967,6 +7283,7 @@
           <a:lstStyle/>
           <a:p>
             <a:pPr algn="ctr"/>
+            <a:endParaRPr/>
           </a:p>
         </p:txBody>
       </p:sp>
@@ -7010,6 +7327,7 @@
           <a:lstStyle/>
           <a:p>
             <a:pPr algn="ctr"/>
+            <a:endParaRPr/>
           </a:p>
         </p:txBody>
       </p:sp>
@@ -7043,6 +7361,7 @@
               </a:defRPr>
             </a:pPr>
             <a:r>
+              <a:rPr dirty="0"/>
               <a:t>7. LATER</a:t>
             </a:r>
           </a:p>
@@ -7090,6 +7409,7 @@
           <a:lstStyle/>
           <a:p>
             <a:pPr algn="ctr"/>
+            <a:endParaRPr/>
           </a:p>
         </p:txBody>
       </p:sp>
@@ -7123,7 +7443,12 @@
               </a:defRPr>
             </a:pPr>
             <a:r>
-              <a:t>tqm_report, Pareto chart, and FMEA matrix read logs for continuous improvement.</a:t>
+              <a:rPr dirty="0" err="1"/>
+              <a:t>tqm_report</a:t>
+            </a:r>
+            <a:r>
+              <a:rPr dirty="0"/>
+              <a:t>, Pareto chart, and FMEA matrix read logs for continuous improvement.</a:t>
             </a:r>
           </a:p>
         </p:txBody>
@@ -7137,7 +7462,7 @@
 </file>
 
 <file path=ppt/slides/slide13.xml><?xml version="1.0" encoding="utf-8"?>
-<p:sld xmlns:a="http://schemas.openxmlformats.org/drawingml/2006/main" xmlns:p="http://schemas.openxmlformats.org/presentationml/2006/main" xmlns:r="http://schemas.openxmlformats.org/officeDocument/2006/relationships">
+<p:sld xmlns:a="http://schemas.openxmlformats.org/drawingml/2006/main" xmlns:r="http://schemas.openxmlformats.org/officeDocument/2006/relationships" xmlns:p="http://schemas.openxmlformats.org/presentationml/2006/main">
   <p:cSld>
     <p:spTree>
       <p:nvGrpSpPr>
@@ -7145,7 +7470,14 @@
         <p:cNvGrpSpPr/>
         <p:nvPr/>
       </p:nvGrpSpPr>
-      <p:grpSpPr/>
+      <p:grpSpPr>
+        <a:xfrm>
+          <a:off x="0" y="0"/>
+          <a:ext cx="0" cy="0"/>
+          <a:chOff x="0" y="0"/>
+          <a:chExt cx="0" cy="0"/>
+        </a:xfrm>
+      </p:grpSpPr>
       <p:sp>
         <p:nvSpPr>
           <p:cNvPr id="2" name="Rectangle 1"/>
@@ -7186,6 +7518,7 @@
           <a:lstStyle/>
           <a:p>
             <a:pPr algn="ctr"/>
+            <a:endParaRPr/>
           </a:p>
         </p:txBody>
       </p:sp>
@@ -7254,6 +7587,7 @@
               </a:defRPr>
             </a:pPr>
             <a:r>
+              <a:rPr dirty="0"/>
               <a:t>TQM Quality Tools — FMEA Risk Analysis &amp; PDCA Cycle</a:t>
             </a:r>
           </a:p>
@@ -7336,6 +7670,7 @@
           <a:lstStyle/>
           <a:p>
             <a:pPr algn="ctr"/>
+            <a:endParaRPr/>
           </a:p>
         </p:txBody>
       </p:sp>
@@ -7379,6 +7714,7 @@
           <a:lstStyle/>
           <a:p>
             <a:pPr algn="ctr"/>
+            <a:endParaRPr/>
           </a:p>
         </p:txBody>
       </p:sp>
@@ -7415,6 +7751,7 @@
               </a:defRPr>
             </a:pPr>
             <a:r>
+              <a:rPr dirty="0"/>
               <a:t>FMEA RISK MITIGATION (RPN = S x O x D)</a:t>
             </a:r>
           </a:p>
@@ -7430,6 +7767,7 @@
               </a:defRPr>
             </a:pPr>
             <a:r>
+              <a:rPr dirty="0"/>
               <a:t>FAILURE MODE             INIT  REV   MITIGATION ACTION</a:t>
             </a:r>
           </a:p>
@@ -7445,7 +7783,16 @@
               </a:defRPr>
             </a:pPr>
             <a:r>
-              <a:t>Tab switch cheating      336   48    FocusOut listener + alert log (-85.7%)</a:t>
+              <a:rPr dirty="0"/>
+              <a:t>Tab switch cheating      336   48    </a:t>
+            </a:r>
+            <a:r>
+              <a:rPr dirty="0" err="1"/>
+              <a:t>FocusOut</a:t>
+            </a:r>
+            <a:r>
+              <a:rPr dirty="0"/>
+              <a:t> listener + alert log (-85.7%)</a:t>
             </a:r>
           </a:p>
           <a:p>
@@ -7460,6 +7807,7 @@
               </a:defRPr>
             </a:pPr>
             <a:r>
+              <a:rPr dirty="0"/>
               <a:t>Lost answer on crash     270   36    Local cache &amp; SQLite auto-save (-86.7%)</a:t>
             </a:r>
           </a:p>
@@ -7475,6 +7823,7 @@
               </a:defRPr>
             </a:pPr>
             <a:r>
+              <a:rPr dirty="0"/>
               <a:t>Malformed question entry 175   21    Poka-yoke dialog validation (-88.0%)</a:t>
             </a:r>
           </a:p>
@@ -7490,6 +7839,7 @@
               </a:defRPr>
             </a:pPr>
             <a:r>
+              <a:rPr dirty="0"/>
               <a:t>Database corruption      150   30    Auto timestamped snapshots in backups/ (-80.0%)</a:t>
             </a:r>
           </a:p>
@@ -7505,6 +7855,7 @@
               </a:defRPr>
             </a:pPr>
             <a:r>
+              <a:rPr dirty="0"/>
               <a:t>Invalid Join Code        144   16    Auto-uppercase &amp; instant pre-flight (-88.9%)</a:t>
             </a:r>
           </a:p>
@@ -7552,6 +7903,7 @@
           <a:lstStyle/>
           <a:p>
             <a:pPr algn="ctr"/>
+            <a:endParaRPr/>
           </a:p>
         </p:txBody>
       </p:sp>
@@ -7595,6 +7947,7 @@
           <a:lstStyle/>
           <a:p>
             <a:pPr algn="ctr"/>
+            <a:endParaRPr/>
           </a:p>
         </p:txBody>
       </p:sp>
@@ -7631,6 +7984,7 @@
               </a:defRPr>
             </a:pPr>
             <a:r>
+              <a:rPr dirty="0"/>
               <a:t>PDCA CONTINUOUS QUALITY CYCLE</a:t>
             </a:r>
           </a:p>
@@ -7639,13 +7993,14 @@
               <a:spcBef>
                 <a:spcPts val="400"/>
               </a:spcBef>
-              <a:defRPr b="1" sz="1000">
+              <a:defRPr sz="1000" b="1">
                 <a:solidFill>
                   <a:srgbClr val="F59E0B"/>
                 </a:solidFill>
               </a:defRPr>
             </a:pPr>
             <a:r>
+              <a:rPr dirty="0"/>
               <a:t>• PLAN:</a:t>
             </a:r>
           </a:p>
@@ -7658,6 +8013,7 @@
               </a:defRPr>
             </a:pPr>
             <a:r>
+              <a:rPr dirty="0"/>
               <a:t>  Identify submission lag and unmonitored cheating. Target &lt;250ms and 100% violation detection.</a:t>
             </a:r>
           </a:p>
@@ -7666,13 +8022,14 @@
               <a:spcBef>
                 <a:spcPts val="400"/>
               </a:spcBef>
-              <a:defRPr b="1" sz="1000">
+              <a:defRPr sz="1000" b="1">
                 <a:solidFill>
                   <a:srgbClr val="F59E0B"/>
                 </a:solidFill>
               </a:defRPr>
             </a:pPr>
             <a:r>
+              <a:rPr dirty="0"/>
               <a:t>• DO:</a:t>
             </a:r>
           </a:p>
@@ -7685,7 +8042,24 @@
               </a:defRPr>
             </a:pPr>
             <a:r>
-              <a:t>  Implement CustomTkinter desktop GUI, FastAPI backend, and window-blur proctor listeners.</a:t>
+              <a:rPr dirty="0"/>
+              <a:t>  Implement </a:t>
+            </a:r>
+            <a:r>
+              <a:rPr dirty="0" err="1"/>
+              <a:t>CustomTkinter</a:t>
+            </a:r>
+            <a:r>
+              <a:rPr dirty="0"/>
+              <a:t> desktop GUI, </a:t>
+            </a:r>
+            <a:r>
+              <a:rPr dirty="0" err="1"/>
+              <a:t>FastAPI</a:t>
+            </a:r>
+            <a:r>
+              <a:rPr dirty="0"/>
+              <a:t> backend, and window-blur proctor listeners.</a:t>
             </a:r>
           </a:p>
           <a:p>
@@ -7693,13 +8067,14 @@
               <a:spcBef>
                 <a:spcPts val="400"/>
               </a:spcBef>
-              <a:defRPr b="1" sz="1000">
+              <a:defRPr sz="1000" b="1">
                 <a:solidFill>
                   <a:srgbClr val="F59E0B"/>
                 </a:solidFill>
               </a:defRPr>
             </a:pPr>
             <a:r>
+              <a:rPr dirty="0"/>
               <a:t>• CHECK:</a:t>
             </a:r>
           </a:p>
@@ -7712,6 +8087,7 @@
               </a:defRPr>
             </a:pPr>
             <a:r>
+              <a:rPr dirty="0"/>
               <a:t>  Audit logs; run Pareto 80/20 analysis; verify RPN dropped from 336 to 48.</a:t>
             </a:r>
           </a:p>
@@ -7720,13 +8096,14 @@
               <a:spcBef>
                 <a:spcPts val="400"/>
               </a:spcBef>
-              <a:defRPr b="1" sz="1000">
+              <a:defRPr sz="1000" b="1">
                 <a:solidFill>
                   <a:srgbClr val="F59E0B"/>
                 </a:solidFill>
               </a:defRPr>
             </a:pPr>
             <a:r>
+              <a:rPr dirty="0"/>
               <a:t>• ACT:</a:t>
             </a:r>
           </a:p>
@@ -7739,6 +8116,7 @@
               </a:defRPr>
             </a:pPr>
             <a:r>
+              <a:rPr dirty="0"/>
               <a:t>  Standardize anti-cheat proctoring and automated daily database backups across all releases.</a:t>
             </a:r>
           </a:p>
@@ -7753,7 +8131,7 @@
 </file>
 
 <file path=ppt/slides/slide14.xml><?xml version="1.0" encoding="utf-8"?>
-<p:sld xmlns:a="http://schemas.openxmlformats.org/drawingml/2006/main" xmlns:p="http://schemas.openxmlformats.org/presentationml/2006/main" xmlns:r="http://schemas.openxmlformats.org/officeDocument/2006/relationships">
+<p:sld xmlns:a="http://schemas.openxmlformats.org/drawingml/2006/main" xmlns:r="http://schemas.openxmlformats.org/officeDocument/2006/relationships" xmlns:p="http://schemas.openxmlformats.org/presentationml/2006/main">
   <p:cSld>
     <p:spTree>
       <p:nvGrpSpPr>
@@ -7761,7 +8139,14 @@
         <p:cNvGrpSpPr/>
         <p:nvPr/>
       </p:nvGrpSpPr>
-      <p:grpSpPr/>
+      <p:grpSpPr>
+        <a:xfrm>
+          <a:off x="0" y="0"/>
+          <a:ext cx="0" cy="0"/>
+          <a:chOff x="0" y="0"/>
+          <a:chExt cx="0" cy="0"/>
+        </a:xfrm>
+      </p:grpSpPr>
       <p:sp>
         <p:nvSpPr>
           <p:cNvPr id="2" name="Rectangle 1"/>
@@ -7802,6 +8187,7 @@
           <a:lstStyle/>
           <a:p>
             <a:pPr algn="ctr"/>
+            <a:endParaRPr/>
           </a:p>
         </p:txBody>
       </p:sp>
@@ -7835,6 +8221,7 @@
               </a:defRPr>
             </a:pPr>
             <a:r>
+              <a:rPr dirty="0"/>
               <a:t>SRS REVIEW 1 &amp; 2 · PROCESS + QUALITY</a:t>
             </a:r>
           </a:p>
@@ -7870,6 +8257,7 @@
               </a:defRPr>
             </a:pPr>
             <a:r>
+              <a:rPr dirty="0"/>
               <a:t>TQM Quality Tools — Quality Dashboard, Pareto &amp; Fishbone</a:t>
             </a:r>
           </a:p>
@@ -7952,6 +8340,7 @@
           <a:lstStyle/>
           <a:p>
             <a:pPr algn="ctr"/>
+            <a:endParaRPr/>
           </a:p>
         </p:txBody>
       </p:sp>
@@ -7995,6 +8384,7 @@
           <a:lstStyle/>
           <a:p>
             <a:pPr algn="ctr"/>
+            <a:endParaRPr/>
           </a:p>
         </p:txBody>
       </p:sp>
@@ -8028,6 +8418,7 @@
               </a:defRPr>
             </a:pPr>
             <a:r>
+              <a:rPr dirty="0"/>
               <a:t>Grading Accuracy</a:t>
             </a:r>
           </a:p>
@@ -8040,6 +8431,7 @@
               </a:defRPr>
             </a:pPr>
             <a:r>
+              <a:rPr dirty="0"/>
               <a:t>100.0%</a:t>
             </a:r>
           </a:p>
@@ -8087,6 +8479,7 @@
           <a:lstStyle/>
           <a:p>
             <a:pPr algn="ctr"/>
+            <a:endParaRPr/>
           </a:p>
         </p:txBody>
       </p:sp>
@@ -8130,6 +8523,7 @@
           <a:lstStyle/>
           <a:p>
             <a:pPr algn="ctr"/>
+            <a:endParaRPr/>
           </a:p>
         </p:txBody>
       </p:sp>
@@ -8163,6 +8557,7 @@
               </a:defRPr>
             </a:pPr>
             <a:r>
+              <a:rPr dirty="0"/>
               <a:t>Average Latency</a:t>
             </a:r>
           </a:p>
@@ -8175,8 +8570,14 @@
               </a:defRPr>
             </a:pPr>
             <a:r>
-              <a:t>24.8 ms</a:t>
-            </a:r>
+              <a:rPr dirty="0"/>
+              <a:t>24.8 </a:t>
+            </a:r>
+            <a:r>
+              <a:rPr dirty="0" err="1"/>
+              <a:t>ms</a:t>
+            </a:r>
+            <a:endParaRPr dirty="0"/>
           </a:p>
         </p:txBody>
       </p:sp>
@@ -8222,6 +8623,7 @@
           <a:lstStyle/>
           <a:p>
             <a:pPr algn="ctr"/>
+            <a:endParaRPr/>
           </a:p>
         </p:txBody>
       </p:sp>
@@ -8265,6 +8667,7 @@
           <a:lstStyle/>
           <a:p>
             <a:pPr algn="ctr"/>
+            <a:endParaRPr/>
           </a:p>
         </p:txBody>
       </p:sp>
@@ -8357,6 +8760,7 @@
           <a:lstStyle/>
           <a:p>
             <a:pPr algn="ctr"/>
+            <a:endParaRPr/>
           </a:p>
         </p:txBody>
       </p:sp>
@@ -8400,6 +8804,7 @@
           <a:lstStyle/>
           <a:p>
             <a:pPr algn="ctr"/>
+            <a:endParaRPr/>
           </a:p>
         </p:txBody>
       </p:sp>
@@ -8492,6 +8897,7 @@
           <a:lstStyle/>
           <a:p>
             <a:pPr algn="ctr"/>
+            <a:endParaRPr/>
           </a:p>
         </p:txBody>
       </p:sp>
@@ -8535,6 +8941,7 @@
           <a:lstStyle/>
           <a:p>
             <a:pPr algn="ctr"/>
+            <a:endParaRPr/>
           </a:p>
         </p:txBody>
       </p:sp>
@@ -8693,6 +9100,7 @@
           <a:lstStyle/>
           <a:p>
             <a:pPr algn="ctr"/>
+            <a:endParaRPr/>
           </a:p>
         </p:txBody>
       </p:sp>
@@ -8736,6 +9144,7 @@
           <a:lstStyle/>
           <a:p>
             <a:pPr algn="ctr"/>
+            <a:endParaRPr/>
           </a:p>
         </p:txBody>
       </p:sp>
@@ -8861,7 +9270,7 @@
 </file>
 
 <file path=ppt/slides/slide15.xml><?xml version="1.0" encoding="utf-8"?>
-<p:sld xmlns:a="http://schemas.openxmlformats.org/drawingml/2006/main" xmlns:p="http://schemas.openxmlformats.org/presentationml/2006/main" xmlns:r="http://schemas.openxmlformats.org/officeDocument/2006/relationships">
+<p:sld xmlns:a="http://schemas.openxmlformats.org/drawingml/2006/main" xmlns:r="http://schemas.openxmlformats.org/officeDocument/2006/relationships" xmlns:p="http://schemas.openxmlformats.org/presentationml/2006/main">
   <p:cSld>
     <p:spTree>
       <p:nvGrpSpPr>
@@ -8869,7 +9278,14 @@
         <p:cNvGrpSpPr/>
         <p:nvPr/>
       </p:nvGrpSpPr>
-      <p:grpSpPr/>
+      <p:grpSpPr>
+        <a:xfrm>
+          <a:off x="0" y="0"/>
+          <a:ext cx="0" cy="0"/>
+          <a:chOff x="0" y="0"/>
+          <a:chExt cx="0" cy="0"/>
+        </a:xfrm>
+      </p:grpSpPr>
       <p:sp>
         <p:nvSpPr>
           <p:cNvPr id="2" name="Rectangle 1"/>
@@ -8910,6 +9326,7 @@
           <a:lstStyle/>
           <a:p>
             <a:pPr algn="ctr"/>
+            <a:endParaRPr/>
           </a:p>
         </p:txBody>
       </p:sp>
@@ -9060,6 +9477,7 @@
           <a:lstStyle/>
           <a:p>
             <a:pPr algn="ctr"/>
+            <a:endParaRPr/>
           </a:p>
         </p:txBody>
       </p:sp>
@@ -9103,6 +9521,7 @@
           <a:lstStyle/>
           <a:p>
             <a:pPr algn="ctr"/>
+            <a:endParaRPr/>
           </a:p>
         </p:txBody>
       </p:sp>
@@ -9147,7 +9566,7 @@
               <a:spcBef>
                 <a:spcPts val="400"/>
               </a:spcBef>
-              <a:defRPr b="1" sz="1050">
+              <a:defRPr sz="1050" b="1">
                 <a:solidFill>
                   <a:srgbClr val="FFFFFF"/>
                 </a:solidFill>
@@ -9178,7 +9597,7 @@
               <a:spcBef>
                 <a:spcPts val="400"/>
               </a:spcBef>
-              <a:defRPr b="1" sz="1050">
+              <a:defRPr sz="1050" b="1">
                 <a:solidFill>
                   <a:srgbClr val="FFFFFF"/>
                 </a:solidFill>
@@ -9209,7 +9628,7 @@
               <a:spcBef>
                 <a:spcPts val="400"/>
               </a:spcBef>
-              <a:defRPr b="1" sz="1050">
+              <a:defRPr sz="1050" b="1">
                 <a:solidFill>
                   <a:srgbClr val="FFFFFF"/>
                 </a:solidFill>
@@ -9279,6 +9698,7 @@
           <a:lstStyle/>
           <a:p>
             <a:pPr algn="ctr"/>
+            <a:endParaRPr/>
           </a:p>
         </p:txBody>
       </p:sp>
@@ -9322,6 +9742,7 @@
           <a:lstStyle/>
           <a:p>
             <a:pPr algn="ctr"/>
+            <a:endParaRPr/>
           </a:p>
         </p:txBody>
       </p:sp>
@@ -9366,7 +9787,7 @@
               <a:spcBef>
                 <a:spcPts val="400"/>
               </a:spcBef>
-              <a:defRPr b="1" sz="1050">
+              <a:defRPr sz="1050" b="1">
                 <a:solidFill>
                   <a:srgbClr val="F59E0B"/>
                 </a:solidFill>
@@ -9405,7 +9826,7 @@
               <a:spcBef>
                 <a:spcPts val="400"/>
               </a:spcBef>
-              <a:defRPr b="1" sz="1050">
+              <a:defRPr sz="1050" b="1">
                 <a:solidFill>
                   <a:srgbClr val="F59E0B"/>
                 </a:solidFill>
@@ -9444,7 +9865,7 @@
               <a:spcBef>
                 <a:spcPts val="400"/>
               </a:spcBef>
-              <a:defRPr b="1" sz="1050">
+              <a:defRPr sz="1050" b="1">
                 <a:solidFill>
                   <a:srgbClr val="F59E0B"/>
                 </a:solidFill>
@@ -9489,7 +9910,7 @@
 </file>
 
 <file path=ppt/slides/slide16.xml><?xml version="1.0" encoding="utf-8"?>
-<p:sld xmlns:a="http://schemas.openxmlformats.org/drawingml/2006/main" xmlns:p="http://schemas.openxmlformats.org/presentationml/2006/main" xmlns:r="http://schemas.openxmlformats.org/officeDocument/2006/relationships">
+<p:sld xmlns:a="http://schemas.openxmlformats.org/drawingml/2006/main" xmlns:r="http://schemas.openxmlformats.org/officeDocument/2006/relationships" xmlns:p="http://schemas.openxmlformats.org/presentationml/2006/main">
   <p:cSld>
     <p:spTree>
       <p:nvGrpSpPr>
@@ -9497,7 +9918,14 @@
         <p:cNvGrpSpPr/>
         <p:nvPr/>
       </p:nvGrpSpPr>
-      <p:grpSpPr/>
+      <p:grpSpPr>
+        <a:xfrm>
+          <a:off x="0" y="0"/>
+          <a:ext cx="0" cy="0"/>
+          <a:chOff x="0" y="0"/>
+          <a:chExt cx="0" cy="0"/>
+        </a:xfrm>
+      </p:grpSpPr>
       <p:sp>
         <p:nvSpPr>
           <p:cNvPr id="2" name="Rectangle 1"/>
@@ -9538,6 +9966,7 @@
           <a:lstStyle/>
           <a:p>
             <a:pPr algn="ctr"/>
+            <a:endParaRPr/>
           </a:p>
         </p:txBody>
       </p:sp>
@@ -9688,6 +10117,7 @@
           <a:lstStyle/>
           <a:p>
             <a:pPr algn="ctr"/>
+            <a:endParaRPr/>
           </a:p>
         </p:txBody>
       </p:sp>
@@ -9731,6 +10161,7 @@
           <a:lstStyle/>
           <a:p>
             <a:pPr algn="ctr"/>
+            <a:endParaRPr/>
           </a:p>
         </p:txBody>
       </p:sp>
@@ -9904,6 +10335,7 @@
           <a:lstStyle/>
           <a:p>
             <a:pPr algn="ctr"/>
+            <a:endParaRPr/>
           </a:p>
         </p:txBody>
       </p:sp>
@@ -9947,6 +10379,7 @@
           <a:lstStyle/>
           <a:p>
             <a:pPr algn="ctr"/>
+            <a:endParaRPr/>
           </a:p>
         </p:txBody>
       </p:sp>
@@ -10105,6 +10538,7 @@
           <a:lstStyle/>
           <a:p>
             <a:pPr algn="ctr"/>
+            <a:endParaRPr/>
           </a:p>
         </p:txBody>
       </p:sp>
@@ -10148,6 +10582,7 @@
           <a:lstStyle/>
           <a:p>
             <a:pPr algn="ctr"/>
+            <a:endParaRPr/>
           </a:p>
         </p:txBody>
       </p:sp>
@@ -10288,7 +10723,7 @@
 </file>
 
 <file path=ppt/slides/slide17.xml><?xml version="1.0" encoding="utf-8"?>
-<p:sld xmlns:a="http://schemas.openxmlformats.org/drawingml/2006/main" xmlns:p="http://schemas.openxmlformats.org/presentationml/2006/main" xmlns:r="http://schemas.openxmlformats.org/officeDocument/2006/relationships">
+<p:sld xmlns:a="http://schemas.openxmlformats.org/drawingml/2006/main" xmlns:r="http://schemas.openxmlformats.org/officeDocument/2006/relationships" xmlns:p="http://schemas.openxmlformats.org/presentationml/2006/main">
   <p:cSld>
     <p:spTree>
       <p:nvGrpSpPr>
@@ -10296,7 +10731,14 @@
         <p:cNvGrpSpPr/>
         <p:nvPr/>
       </p:nvGrpSpPr>
-      <p:grpSpPr/>
+      <p:grpSpPr>
+        <a:xfrm>
+          <a:off x="0" y="0"/>
+          <a:ext cx="0" cy="0"/>
+          <a:chOff x="0" y="0"/>
+          <a:chExt cx="0" cy="0"/>
+        </a:xfrm>
+      </p:grpSpPr>
       <p:sp>
         <p:nvSpPr>
           <p:cNvPr id="2" name="Rectangle 1"/>
@@ -10337,6 +10779,7 @@
           <a:lstStyle/>
           <a:p>
             <a:pPr algn="ctr"/>
+            <a:endParaRPr/>
           </a:p>
         </p:txBody>
       </p:sp>
@@ -10487,6 +10930,7 @@
           <a:lstStyle/>
           <a:p>
             <a:pPr algn="ctr"/>
+            <a:endParaRPr/>
           </a:p>
         </p:txBody>
       </p:sp>
@@ -10530,6 +10974,7 @@
           <a:lstStyle/>
           <a:p>
             <a:pPr algn="ctr"/>
+            <a:endParaRPr/>
           </a:p>
         </p:txBody>
       </p:sp>
@@ -10733,6 +11178,7 @@
           <a:lstStyle/>
           <a:p>
             <a:pPr algn="ctr"/>
+            <a:endParaRPr/>
           </a:p>
         </p:txBody>
       </p:sp>
@@ -10776,6 +11222,7 @@
           <a:lstStyle/>
           <a:p>
             <a:pPr algn="ctr"/>
+            <a:endParaRPr/>
           </a:p>
         </p:txBody>
       </p:sp>
@@ -10901,7 +11348,7 @@
 </file>
 
 <file path=ppt/slides/slide2.xml><?xml version="1.0" encoding="utf-8"?>
-<p:sld xmlns:a="http://schemas.openxmlformats.org/drawingml/2006/main" xmlns:p="http://schemas.openxmlformats.org/presentationml/2006/main" xmlns:r="http://schemas.openxmlformats.org/officeDocument/2006/relationships">
+<p:sld xmlns:a="http://schemas.openxmlformats.org/drawingml/2006/main" xmlns:r="http://schemas.openxmlformats.org/officeDocument/2006/relationships" xmlns:p="http://schemas.openxmlformats.org/presentationml/2006/main">
   <p:cSld>
     <p:spTree>
       <p:nvGrpSpPr>
@@ -10909,7 +11356,14 @@
         <p:cNvGrpSpPr/>
         <p:nvPr/>
       </p:nvGrpSpPr>
-      <p:grpSpPr/>
+      <p:grpSpPr>
+        <a:xfrm>
+          <a:off x="0" y="0"/>
+          <a:ext cx="0" cy="0"/>
+          <a:chOff x="0" y="0"/>
+          <a:chExt cx="0" cy="0"/>
+        </a:xfrm>
+      </p:grpSpPr>
       <p:sp>
         <p:nvSpPr>
           <p:cNvPr id="2" name="Rectangle 1"/>
@@ -10950,6 +11404,7 @@
           <a:lstStyle/>
           <a:p>
             <a:pPr algn="ctr"/>
+            <a:endParaRPr/>
           </a:p>
         </p:txBody>
       </p:sp>
@@ -11018,6 +11473,7 @@
               </a:defRPr>
             </a:pPr>
             <a:r>
+              <a:rPr dirty="0"/>
               <a:t>Problem Statement &amp; Baseline Understanding</a:t>
             </a:r>
           </a:p>
@@ -11100,6 +11556,7 @@
           <a:lstStyle/>
           <a:p>
             <a:pPr algn="ctr"/>
+            <a:endParaRPr/>
           </a:p>
         </p:txBody>
       </p:sp>
@@ -11143,6 +11600,7 @@
           <a:lstStyle/>
           <a:p>
             <a:pPr algn="ctr"/>
+            <a:endParaRPr/>
           </a:p>
         </p:txBody>
       </p:sp>
@@ -11179,6 +11637,7 @@
               </a:defRPr>
             </a:pPr>
             <a:r>
+              <a:rPr dirty="0"/>
               <a:t>TRADITIONAL SYSTEM PAIN POINTS</a:t>
             </a:r>
           </a:p>
@@ -11187,13 +11646,14 @@
               <a:spcBef>
                 <a:spcPts val="400"/>
               </a:spcBef>
-              <a:defRPr b="1" sz="1100">
+              <a:defRPr sz="1100" b="1">
                 <a:solidFill>
                   <a:srgbClr val="FFFFFF"/>
                 </a:solidFill>
               </a:defRPr>
             </a:pPr>
             <a:r>
+              <a:rPr dirty="0"/>
               <a:t>• Submission Hangs &amp; Data Loss:</a:t>
             </a:r>
           </a:p>
@@ -11206,6 +11666,7 @@
               </a:defRPr>
             </a:pPr>
             <a:r>
+              <a:rPr dirty="0"/>
               <a:t>  Network lag causes timeouts; student answers are lost unrecorded.</a:t>
             </a:r>
           </a:p>
@@ -11214,13 +11675,14 @@
               <a:spcBef>
                 <a:spcPts val="400"/>
               </a:spcBef>
-              <a:defRPr b="1" sz="1100">
+              <a:defRPr sz="1100" b="1">
                 <a:solidFill>
                   <a:srgbClr val="FFFFFF"/>
                 </a:solidFill>
               </a:defRPr>
             </a:pPr>
             <a:r>
+              <a:rPr dirty="0"/>
               <a:t>• Academic Dishonesty:</a:t>
             </a:r>
           </a:p>
@@ -11233,6 +11695,7 @@
               </a:defRPr>
             </a:pPr>
             <a:r>
+              <a:rPr dirty="0"/>
               <a:t>  No active focus monitoring; students easily switch tabs to cheat.</a:t>
             </a:r>
           </a:p>
@@ -11241,13 +11704,14 @@
               <a:spcBef>
                 <a:spcPts val="400"/>
               </a:spcBef>
-              <a:defRPr b="1" sz="1100">
+              <a:defRPr sz="1100" b="1">
                 <a:solidFill>
                   <a:srgbClr val="FFFFFF"/>
                 </a:solidFill>
               </a:defRPr>
             </a:pPr>
             <a:r>
+              <a:rPr dirty="0"/>
               <a:t>• Manual Teacher Burden:</a:t>
             </a:r>
           </a:p>
@@ -11260,6 +11724,7 @@
               </a:defRPr>
             </a:pPr>
             <a:r>
+              <a:rPr dirty="0"/>
               <a:t>  Hours wasted formatting question sheets, scoring, and tabulating.</a:t>
             </a:r>
           </a:p>
@@ -11268,13 +11733,14 @@
               <a:spcBef>
                 <a:spcPts val="400"/>
               </a:spcBef>
-              <a:defRPr b="1" sz="1100">
+              <a:defRPr sz="1100" b="1">
                 <a:solidFill>
                   <a:srgbClr val="FFFFFF"/>
                 </a:solidFill>
               </a:defRPr>
             </a:pPr>
             <a:r>
+              <a:rPr dirty="0"/>
               <a:t>• Single Point of Failure:</a:t>
             </a:r>
           </a:p>
@@ -11287,6 +11753,7 @@
               </a:defRPr>
             </a:pPr>
             <a:r>
+              <a:rPr dirty="0"/>
               <a:t>  No automated local database snapshotting; server crashes cause fatal exam loss.</a:t>
             </a:r>
           </a:p>
@@ -11334,6 +11801,7 @@
           <a:lstStyle/>
           <a:p>
             <a:pPr algn="ctr"/>
+            <a:endParaRPr/>
           </a:p>
         </p:txBody>
       </p:sp>
@@ -11377,6 +11845,7 @@
           <a:lstStyle/>
           <a:p>
             <a:pPr algn="ctr"/>
+            <a:endParaRPr/>
           </a:p>
         </p:txBody>
       </p:sp>
@@ -11413,6 +11882,7 @@
               </a:defRPr>
             </a:pPr>
             <a:r>
+              <a:rPr dirty="0"/>
               <a:t>QUIZSPHERE PRO ARCHITECTURAL SOLUTION</a:t>
             </a:r>
           </a:p>
@@ -11421,13 +11891,14 @@
               <a:spcBef>
                 <a:spcPts val="400"/>
               </a:spcBef>
-              <a:defRPr b="1" sz="1100">
+              <a:defRPr sz="1100" b="1">
                 <a:solidFill>
                   <a:srgbClr val="10B981"/>
                 </a:solidFill>
               </a:defRPr>
             </a:pPr>
             <a:r>
+              <a:rPr dirty="0"/>
               <a:t>✔ Sub-250ms Instant Evaluation:</a:t>
             </a:r>
           </a:p>
@@ -11440,6 +11911,7 @@
               </a:defRPr>
             </a:pPr>
             <a:r>
+              <a:rPr dirty="0"/>
               <a:t>  In-memory deterministic scoring grades tests in 15-35 milliseconds.</a:t>
             </a:r>
           </a:p>
@@ -11448,13 +11920,14 @@
               <a:spcBef>
                 <a:spcPts val="400"/>
               </a:spcBef>
-              <a:defRPr b="1" sz="1100">
+              <a:defRPr sz="1100" b="1">
                 <a:solidFill>
                   <a:srgbClr val="10B981"/>
                 </a:solidFill>
               </a:defRPr>
             </a:pPr>
             <a:r>
+              <a:rPr dirty="0"/>
               <a:t>✔ Anti-Cheat Proctoring Hub:</a:t>
             </a:r>
           </a:p>
@@ -11467,6 +11940,7 @@
               </a:defRPr>
             </a:pPr>
             <a:r>
+              <a:rPr dirty="0"/>
               <a:t>  Continuous window focus loss and tab-switch telemetry logged in real time.</a:t>
             </a:r>
           </a:p>
@@ -11475,13 +11949,14 @@
               <a:spcBef>
                 <a:spcPts val="400"/>
               </a:spcBef>
-              <a:defRPr b="1" sz="1100">
+              <a:defRPr sz="1100" b="1">
                 <a:solidFill>
                   <a:srgbClr val="10B981"/>
                 </a:solidFill>
               </a:defRPr>
             </a:pPr>
             <a:r>
+              <a:rPr dirty="0"/>
               <a:t>✔ AI Curriculum Generation:</a:t>
             </a:r>
           </a:p>
@@ -11494,6 +11969,7 @@
               </a:defRPr>
             </a:pPr>
             <a:r>
+              <a:rPr dirty="0"/>
               <a:t>  Faculty input syllabus topic keywords; 5-20 MCQs synthesized in seconds.</a:t>
             </a:r>
           </a:p>
@@ -11502,13 +11978,14 @@
               <a:spcBef>
                 <a:spcPts val="400"/>
               </a:spcBef>
-              <a:defRPr b="1" sz="1100">
+              <a:defRPr sz="1100" b="1">
                 <a:solidFill>
                   <a:srgbClr val="10B981"/>
                 </a:solidFill>
               </a:defRPr>
             </a:pPr>
             <a:r>
+              <a:rPr dirty="0"/>
               <a:t>✔ Dual Platform Deployment:</a:t>
             </a:r>
           </a:p>
@@ -11521,6 +11998,7 @@
               </a:defRPr>
             </a:pPr>
             <a:r>
+              <a:rPr dirty="0"/>
               <a:t>  Simultaneous access via responsive Web SPA and standalone Windows Desktop App.</a:t>
             </a:r>
           </a:p>
@@ -11535,7 +12013,7 @@
 </file>
 
 <file path=ppt/slides/slide3.xml><?xml version="1.0" encoding="utf-8"?>
-<p:sld xmlns:a="http://schemas.openxmlformats.org/drawingml/2006/main" xmlns:p="http://schemas.openxmlformats.org/presentationml/2006/main" xmlns:r="http://schemas.openxmlformats.org/officeDocument/2006/relationships">
+<p:sld xmlns:a="http://schemas.openxmlformats.org/drawingml/2006/main" xmlns:r="http://schemas.openxmlformats.org/officeDocument/2006/relationships" xmlns:p="http://schemas.openxmlformats.org/presentationml/2006/main">
   <p:cSld>
     <p:spTree>
       <p:nvGrpSpPr>
@@ -11543,50 +12021,14 @@
         <p:cNvGrpSpPr/>
         <p:nvPr/>
       </p:nvGrpSpPr>
-      <p:grpSpPr/>
-      <p:sp>
-        <p:nvSpPr>
-          <p:cNvPr id="2" name="Rectangle 1"/>
-          <p:cNvSpPr/>
-          <p:nvPr/>
-        </p:nvSpPr>
-        <p:spPr>
-          <a:xfrm>
-            <a:off x="0" y="0"/>
-            <a:ext cx="12191695" cy="6858000"/>
-          </a:xfrm>
-          <a:prstGeom prst="rect">
-            <a:avLst/>
-          </a:prstGeom>
-          <a:solidFill>
-            <a:srgbClr val="0F172A"/>
-          </a:solidFill>
-          <a:ln>
-            <a:noFill/>
-          </a:ln>
-        </p:spPr>
-        <p:style>
-          <a:lnRef idx="1">
-            <a:schemeClr val="accent1"/>
-          </a:lnRef>
-          <a:fillRef idx="3">
-            <a:schemeClr val="accent1"/>
-          </a:fillRef>
-          <a:effectRef idx="2">
-            <a:schemeClr val="accent1"/>
-          </a:effectRef>
-          <a:fontRef idx="minor">
-            <a:schemeClr val="lt1"/>
-          </a:fontRef>
-        </p:style>
-        <p:txBody>
-          <a:bodyPr rtlCol="0" anchor="ctr"/>
-          <a:lstStyle/>
-          <a:p>
-            <a:pPr algn="ctr"/>
-          </a:p>
-        </p:txBody>
-      </p:sp>
+      <p:grpSpPr>
+        <a:xfrm>
+          <a:off x="0" y="0"/>
+          <a:ext cx="0" cy="0"/>
+          <a:chOff x="0" y="0"/>
+          <a:chExt cx="0" cy="0"/>
+        </a:xfrm>
+      </p:grpSpPr>
       <p:sp>
         <p:nvSpPr>
           <p:cNvPr id="3" name="TextBox 2"/>
@@ -11652,6 +12094,7 @@
               </a:defRPr>
             </a:pPr>
             <a:r>
+              <a:rPr dirty="0"/>
               <a:t>Vision, Mission &amp; Measurable Quality Objectives (O1–O5)</a:t>
             </a:r>
           </a:p>
@@ -11734,6 +12177,7 @@
           <a:lstStyle/>
           <a:p>
             <a:pPr algn="ctr"/>
+            <a:endParaRPr/>
           </a:p>
         </p:txBody>
       </p:sp>
@@ -11777,6 +12221,7 @@
           <a:lstStyle/>
           <a:p>
             <a:pPr algn="ctr"/>
+            <a:endParaRPr/>
           </a:p>
         </p:txBody>
       </p:sp>
@@ -11810,6 +12255,7 @@
               </a:defRPr>
             </a:pPr>
             <a:r>
+              <a:rPr dirty="0"/>
               <a:t>VISION: An examination environment where zero unrecorded answers, zero grading latency, and zero undetected infractions occur.</a:t>
             </a:r>
           </a:p>
@@ -11825,6 +12271,7 @@
               </a:defRPr>
             </a:pPr>
             <a:r>
+              <a:rPr dirty="0"/>
               <a:t>MISSION: Build a dual-platform assessment system that records stock attempts, blocks cheating via active proctoring, auto-grades in &lt;250ms, and shows who did what.</a:t>
             </a:r>
           </a:p>
@@ -11872,6 +12319,7 @@
           <a:lstStyle/>
           <a:p>
             <a:pPr algn="ctr"/>
+            <a:endParaRPr/>
           </a:p>
         </p:txBody>
       </p:sp>
@@ -11915,6 +12363,7 @@
           <a:lstStyle/>
           <a:p>
             <a:pPr algn="ctr"/>
+            <a:endParaRPr/>
           </a:p>
         </p:txBody>
       </p:sp>
@@ -11995,6 +12444,7 @@
           <a:lstStyle/>
           <a:p>
             <a:pPr algn="ctr"/>
+            <a:endParaRPr/>
           </a:p>
         </p:txBody>
       </p:sp>
@@ -12075,6 +12525,7 @@
           <a:lstStyle/>
           <a:p>
             <a:pPr algn="ctr"/>
+            <a:endParaRPr/>
           </a:p>
         </p:txBody>
       </p:sp>
@@ -12118,6 +12569,7 @@
           <a:lstStyle/>
           <a:p>
             <a:pPr algn="ctr"/>
+            <a:endParaRPr/>
           </a:p>
         </p:txBody>
       </p:sp>
@@ -12198,6 +12650,7 @@
           <a:lstStyle/>
           <a:p>
             <a:pPr algn="ctr"/>
+            <a:endParaRPr/>
           </a:p>
         </p:txBody>
       </p:sp>
@@ -12278,6 +12731,7 @@
           <a:lstStyle/>
           <a:p>
             <a:pPr algn="ctr"/>
+            <a:endParaRPr/>
           </a:p>
         </p:txBody>
       </p:sp>
@@ -12321,6 +12775,7 @@
           <a:lstStyle/>
           <a:p>
             <a:pPr algn="ctr"/>
+            <a:endParaRPr/>
           </a:p>
         </p:txBody>
       </p:sp>
@@ -12401,6 +12856,7 @@
           <a:lstStyle/>
           <a:p>
             <a:pPr algn="ctr"/>
+            <a:endParaRPr/>
           </a:p>
         </p:txBody>
       </p:sp>
@@ -12481,6 +12937,7 @@
           <a:lstStyle/>
           <a:p>
             <a:pPr algn="ctr"/>
+            <a:endParaRPr/>
           </a:p>
         </p:txBody>
       </p:sp>
@@ -12524,6 +12981,7 @@
           <a:lstStyle/>
           <a:p>
             <a:pPr algn="ctr"/>
+            <a:endParaRPr/>
           </a:p>
         </p:txBody>
       </p:sp>
@@ -12604,6 +13062,7 @@
           <a:lstStyle/>
           <a:p>
             <a:pPr algn="ctr"/>
+            <a:endParaRPr/>
           </a:p>
         </p:txBody>
       </p:sp>
@@ -12684,6 +13143,7 @@
           <a:lstStyle/>
           <a:p>
             <a:pPr algn="ctr"/>
+            <a:endParaRPr/>
           </a:p>
         </p:txBody>
       </p:sp>
@@ -12727,6 +13187,7 @@
           <a:lstStyle/>
           <a:p>
             <a:pPr algn="ctr"/>
+            <a:endParaRPr/>
           </a:p>
         </p:txBody>
       </p:sp>
@@ -12807,6 +13268,7 @@
           <a:lstStyle/>
           <a:p>
             <a:pPr algn="ctr"/>
+            <a:endParaRPr/>
           </a:p>
         </p:txBody>
       </p:sp>
@@ -12854,7 +13316,7 @@
 </file>
 
 <file path=ppt/slides/slide4.xml><?xml version="1.0" encoding="utf-8"?>
-<p:sld xmlns:a="http://schemas.openxmlformats.org/drawingml/2006/main" xmlns:p="http://schemas.openxmlformats.org/presentationml/2006/main" xmlns:r="http://schemas.openxmlformats.org/officeDocument/2006/relationships">
+<p:sld xmlns:a="http://schemas.openxmlformats.org/drawingml/2006/main" xmlns:r="http://schemas.openxmlformats.org/officeDocument/2006/relationships" xmlns:p="http://schemas.openxmlformats.org/presentationml/2006/main">
   <p:cSld>
     <p:spTree>
       <p:nvGrpSpPr>
@@ -12862,7 +13324,14 @@
         <p:cNvGrpSpPr/>
         <p:nvPr/>
       </p:nvGrpSpPr>
-      <p:grpSpPr/>
+      <p:grpSpPr>
+        <a:xfrm>
+          <a:off x="0" y="0"/>
+          <a:ext cx="0" cy="0"/>
+          <a:chOff x="0" y="0"/>
+          <a:chExt cx="0" cy="0"/>
+        </a:xfrm>
+      </p:grpSpPr>
       <p:sp>
         <p:nvSpPr>
           <p:cNvPr id="2" name="Rectangle 1"/>
@@ -12903,6 +13372,7 @@
           <a:lstStyle/>
           <a:p>
             <a:pPr algn="ctr"/>
+            <a:endParaRPr/>
           </a:p>
         </p:txBody>
       </p:sp>
@@ -12971,6 +13441,7 @@
               </a:defRPr>
             </a:pPr>
             <a:r>
+              <a:rPr dirty="0"/>
               <a:t>Three Quality Ideas &amp; Feature-to-Quality Mapping</a:t>
             </a:r>
           </a:p>
@@ -13053,6 +13524,7 @@
           <a:lstStyle/>
           <a:p>
             <a:pPr algn="ctr"/>
+            <a:endParaRPr/>
           </a:p>
         </p:txBody>
       </p:sp>
@@ -13096,6 +13568,7 @@
           <a:lstStyle/>
           <a:p>
             <a:pPr algn="ctr"/>
+            <a:endParaRPr/>
           </a:p>
         </p:txBody>
       </p:sp>
@@ -13107,7 +13580,7 @@
         </p:nvSpPr>
         <p:spPr>
           <a:xfrm>
-            <a:off x="914400" y="1828800"/>
+            <a:off x="854015" y="1865376"/>
             <a:ext cx="4754880" cy="4114800"/>
           </a:xfrm>
           <a:prstGeom prst="rect">
@@ -13132,6 +13605,7 @@
               </a:defRPr>
             </a:pPr>
             <a:r>
+              <a:rPr dirty="0"/>
               <a:t>THREE QUALITY IDEAS BEHIND THE SYSTEM</a:t>
             </a:r>
           </a:p>
@@ -13140,13 +13614,14 @@
               <a:spcBef>
                 <a:spcPts val="400"/>
               </a:spcBef>
-              <a:defRPr b="1" sz="1050">
+              <a:defRPr sz="1050" b="1">
                 <a:solidFill>
                   <a:srgbClr val="FFFFFF"/>
                 </a:solidFill>
               </a:defRPr>
             </a:pPr>
             <a:r>
+              <a:rPr dirty="0"/>
               <a:t>• 1. Error Prevention at Source (Poka-Yoke):</a:t>
             </a:r>
           </a:p>
@@ -13159,6 +13634,7 @@
               </a:defRPr>
             </a:pPr>
             <a:r>
+              <a:rPr dirty="0"/>
               <a:t>  Blank prompts, missing radio choices, out-of-bounds duration limits, and duplicate Join Codes are hard-blocked.</a:t>
             </a:r>
           </a:p>
@@ -13167,13 +13643,14 @@
               <a:spcBef>
                 <a:spcPts val="400"/>
               </a:spcBef>
-              <a:defRPr b="1" sz="1050">
+              <a:defRPr sz="1050" b="1">
                 <a:solidFill>
                   <a:srgbClr val="FFFFFF"/>
                 </a:solidFill>
               </a:defRPr>
             </a:pPr>
             <a:r>
+              <a:rPr dirty="0"/>
               <a:t>• 2. Process Control (One Path for Work):</a:t>
             </a:r>
           </a:p>
@@ -13186,6 +13663,7 @@
               </a:defRPr>
             </a:pPr>
             <a:r>
+              <a:rPr dirty="0"/>
               <a:t>  Teacher Creates → Code Issued → Candidate Enters → Proctored Exam → Instant Auto-Grade. UI cannot skip rules.</a:t>
             </a:r>
           </a:p>
@@ -13194,13 +13672,14 @@
               <a:spcBef>
                 <a:spcPts val="400"/>
               </a:spcBef>
-              <a:defRPr b="1" sz="1050">
+              <a:defRPr sz="1050" b="1">
                 <a:solidFill>
                   <a:srgbClr val="FFFFFF"/>
                 </a:solidFill>
               </a:defRPr>
             </a:pPr>
             <a:r>
+              <a:rPr dirty="0"/>
               <a:t>• 3. Monitoring (See &amp; Trace):</a:t>
             </a:r>
           </a:p>
@@ -13213,6 +13692,7 @@
               </a:defRPr>
             </a:pPr>
             <a:r>
+              <a:rPr dirty="0"/>
               <a:t>  Real-time dashboard KPI alerts, proctor violation logs, and error telemetry directly feeding FMEA.</a:t>
             </a:r>
           </a:p>
@@ -13260,6 +13740,7 @@
           <a:lstStyle/>
           <a:p>
             <a:pPr algn="ctr"/>
+            <a:endParaRPr/>
           </a:p>
         </p:txBody>
       </p:sp>
@@ -13303,6 +13784,7 @@
           <a:lstStyle/>
           <a:p>
             <a:pPr algn="ctr"/>
+            <a:endParaRPr/>
           </a:p>
         </p:txBody>
       </p:sp>
@@ -13339,6 +13821,7 @@
               </a:defRPr>
             </a:pPr>
             <a:r>
+              <a:rPr dirty="0"/>
               <a:t>FEATURE → TQM QUALITY IDEA MAPPING</a:t>
             </a:r>
           </a:p>
@@ -13347,13 +13830,14 @@
               <a:spcBef>
                 <a:spcPts val="400"/>
               </a:spcBef>
-              <a:defRPr b="1" sz="1050">
+              <a:defRPr sz="1050" b="1">
                 <a:solidFill>
                   <a:srgbClr val="F59E0B"/>
                 </a:solidFill>
               </a:defRPr>
             </a:pPr>
             <a:r>
+              <a:rPr dirty="0"/>
               <a:t>▪ Input Validation:</a:t>
             </a:r>
           </a:p>
@@ -13366,6 +13850,7 @@
               </a:defRPr>
             </a:pPr>
             <a:r>
+              <a:rPr dirty="0"/>
               <a:t>  → Error prevention at source (Poka-yoke)</a:t>
             </a:r>
           </a:p>
@@ -13374,13 +13859,14 @@
               <a:spcBef>
                 <a:spcPts val="400"/>
               </a:spcBef>
-              <a:defRPr b="1" sz="1050">
+              <a:defRPr sz="1050" b="1">
                 <a:solidFill>
                   <a:srgbClr val="F59E0B"/>
                 </a:solidFill>
               </a:defRPr>
             </a:pPr>
             <a:r>
+              <a:rPr dirty="0"/>
               <a:t>▪ User Roles (RBAC):</a:t>
             </a:r>
           </a:p>
@@ -13393,6 +13879,7 @@
               </a:defRPr>
             </a:pPr>
             <a:r>
+              <a:rPr dirty="0"/>
               <a:t>  → Process control + accountability</a:t>
             </a:r>
           </a:p>
@@ -13401,13 +13888,14 @@
               <a:spcBef>
                 <a:spcPts val="400"/>
               </a:spcBef>
-              <a:defRPr b="1" sz="1050">
+              <a:defRPr sz="1050" b="1">
                 <a:solidFill>
                   <a:srgbClr val="F59E0B"/>
                 </a:solidFill>
               </a:defRPr>
             </a:pPr>
             <a:r>
+              <a:rPr dirty="0"/>
               <a:t>▪ Audit Log &amp; Violation Tracker:</a:t>
             </a:r>
           </a:p>
@@ -13420,6 +13908,7 @@
               </a:defRPr>
             </a:pPr>
             <a:r>
+              <a:rPr dirty="0"/>
               <a:t>  → Monitoring + traceability</a:t>
             </a:r>
           </a:p>
@@ -13428,13 +13917,14 @@
               <a:spcBef>
                 <a:spcPts val="400"/>
               </a:spcBef>
-              <a:defRPr b="1" sz="1050">
+              <a:defRPr sz="1050" b="1">
                 <a:solidFill>
                   <a:srgbClr val="F59E0B"/>
                 </a:solidFill>
               </a:defRPr>
             </a:pPr>
             <a:r>
+              <a:rPr dirty="0"/>
               <a:t>▪ Error Recovery (ACID):</a:t>
             </a:r>
           </a:p>
@@ -13447,6 +13937,7 @@
               </a:defRPr>
             </a:pPr>
             <a:r>
+              <a:rPr dirty="0"/>
               <a:t>  → Reliability. No half-submitted tests.</a:t>
             </a:r>
           </a:p>
@@ -13455,13 +13946,14 @@
               <a:spcBef>
                 <a:spcPts val="400"/>
               </a:spcBef>
-              <a:defRPr b="1" sz="1050">
+              <a:defRPr sz="1050" b="1">
                 <a:solidFill>
                   <a:srgbClr val="F59E0B"/>
                 </a:solidFill>
               </a:defRPr>
             </a:pPr>
             <a:r>
+              <a:rPr dirty="0"/>
               <a:t>▪ Auto Backup Engine:</a:t>
             </a:r>
           </a:p>
@@ -13474,6 +13966,7 @@
               </a:defRPr>
             </a:pPr>
             <a:r>
+              <a:rPr dirty="0"/>
               <a:t>  → Reliability. Data is never lost.</a:t>
             </a:r>
           </a:p>
@@ -13488,7 +13981,7 @@
 </file>
 
 <file path=ppt/slides/slide5.xml><?xml version="1.0" encoding="utf-8"?>
-<p:sld xmlns:a="http://schemas.openxmlformats.org/drawingml/2006/main" xmlns:p="http://schemas.openxmlformats.org/presentationml/2006/main" xmlns:r="http://schemas.openxmlformats.org/officeDocument/2006/relationships">
+<p:sld xmlns:a="http://schemas.openxmlformats.org/drawingml/2006/main" xmlns:r="http://schemas.openxmlformats.org/officeDocument/2006/relationships" xmlns:p="http://schemas.openxmlformats.org/presentationml/2006/main">
   <p:cSld>
     <p:spTree>
       <p:nvGrpSpPr>
@@ -13496,50 +13989,14 @@
         <p:cNvGrpSpPr/>
         <p:nvPr/>
       </p:nvGrpSpPr>
-      <p:grpSpPr/>
-      <p:sp>
-        <p:nvSpPr>
-          <p:cNvPr id="2" name="Rectangle 1"/>
-          <p:cNvSpPr/>
-          <p:nvPr/>
-        </p:nvSpPr>
-        <p:spPr>
-          <a:xfrm>
-            <a:off x="0" y="0"/>
-            <a:ext cx="12191695" cy="6858000"/>
-          </a:xfrm>
-          <a:prstGeom prst="rect">
-            <a:avLst/>
-          </a:prstGeom>
-          <a:solidFill>
-            <a:srgbClr val="0F172A"/>
-          </a:solidFill>
-          <a:ln>
-            <a:noFill/>
-          </a:ln>
-        </p:spPr>
-        <p:style>
-          <a:lnRef idx="1">
-            <a:schemeClr val="accent1"/>
-          </a:lnRef>
-          <a:fillRef idx="3">
-            <a:schemeClr val="accent1"/>
-          </a:fillRef>
-          <a:effectRef idx="2">
-            <a:schemeClr val="accent1"/>
-          </a:effectRef>
-          <a:fontRef idx="minor">
-            <a:schemeClr val="lt1"/>
-          </a:fontRef>
-        </p:style>
-        <p:txBody>
-          <a:bodyPr rtlCol="0" anchor="ctr"/>
-          <a:lstStyle/>
-          <a:p>
-            <a:pPr algn="ctr"/>
-          </a:p>
-        </p:txBody>
-      </p:sp>
+      <p:grpSpPr>
+        <a:xfrm>
+          <a:off x="0" y="0"/>
+          <a:ext cx="0" cy="0"/>
+          <a:chOff x="0" y="0"/>
+          <a:chExt cx="0" cy="0"/>
+        </a:xfrm>
+      </p:grpSpPr>
       <p:sp>
         <p:nvSpPr>
           <p:cNvPr id="3" name="TextBox 2"/>
@@ -13605,6 +14062,7 @@
               </a:defRPr>
             </a:pPr>
             <a:r>
+              <a:rPr dirty="0"/>
               <a:t>Process Map, Sitting Controls &amp; SIPOC Matrix</a:t>
             </a:r>
           </a:p>
@@ -14011,6 +14469,7 @@
           <a:lstStyle/>
           <a:p>
             <a:pPr algn="ctr"/>
+            <a:endParaRPr/>
           </a:p>
         </p:txBody>
       </p:sp>
@@ -14054,6 +14513,7 @@
           <a:lstStyle/>
           <a:p>
             <a:pPr algn="ctr"/>
+            <a:endParaRPr/>
           </a:p>
         </p:txBody>
       </p:sp>
@@ -14149,6 +14609,7 @@
           <a:lstStyle/>
           <a:p>
             <a:pPr algn="ctr"/>
+            <a:endParaRPr/>
           </a:p>
         </p:txBody>
       </p:sp>
@@ -14192,6 +14653,7 @@
           <a:lstStyle/>
           <a:p>
             <a:pPr algn="ctr"/>
+            <a:endParaRPr/>
           </a:p>
         </p:txBody>
       </p:sp>
@@ -14287,6 +14749,7 @@
           <a:lstStyle/>
           <a:p>
             <a:pPr algn="ctr"/>
+            <a:endParaRPr/>
           </a:p>
         </p:txBody>
       </p:sp>
@@ -14330,6 +14793,7 @@
           <a:lstStyle/>
           <a:p>
             <a:pPr algn="ctr"/>
+            <a:endParaRPr/>
           </a:p>
         </p:txBody>
       </p:sp>
@@ -14425,6 +14889,7 @@
           <a:lstStyle/>
           <a:p>
             <a:pPr algn="ctr"/>
+            <a:endParaRPr/>
           </a:p>
         </p:txBody>
       </p:sp>
@@ -14468,6 +14933,7 @@
           <a:lstStyle/>
           <a:p>
             <a:pPr algn="ctr"/>
+            <a:endParaRPr/>
           </a:p>
         </p:txBody>
       </p:sp>
@@ -14563,6 +15029,7 @@
           <a:lstStyle/>
           <a:p>
             <a:pPr algn="ctr"/>
+            <a:endParaRPr/>
           </a:p>
         </p:txBody>
       </p:sp>
@@ -14606,6 +15073,7 @@
           <a:lstStyle/>
           <a:p>
             <a:pPr algn="ctr"/>
+            <a:endParaRPr/>
           </a:p>
         </p:txBody>
       </p:sp>
@@ -14642,6 +15110,7 @@
               </a:defRPr>
             </a:pPr>
             <a:r>
+              <a:rPr dirty="0"/>
               <a:t>SIPOC MODEL OF THE ASSESSMENT PROCESS</a:t>
             </a:r>
           </a:p>
@@ -14657,6 +15126,7 @@
               </a:defRPr>
             </a:pPr>
             <a:r>
+              <a:rPr dirty="0"/>
               <a:t>Suppliers (S):   Faculty / Teachers, Curriculum SMEs, AI Question Synthesis Model, Primary SQLite DB.</a:t>
             </a:r>
           </a:p>
@@ -14672,6 +15142,7 @@
               </a:defRPr>
             </a:pPr>
             <a:r>
+              <a:rPr dirty="0"/>
               <a:t>Inputs (I):      Syllabus topic keywords, question prompts, deterministic answer keys, student credentials, Join Codes.</a:t>
             </a:r>
           </a:p>
@@ -14687,6 +15158,7 @@
               </a:defRPr>
             </a:pPr>
             <a:r>
+              <a:rPr dirty="0"/>
               <a:t>Process (P):     Validate Input → Issue Join Code → Launch Timed Proctored Exam → Track Focus → Auto-Grade (&lt;25ms).</a:t>
             </a:r>
           </a:p>
@@ -14702,6 +15174,7 @@
               </a:defRPr>
             </a:pPr>
             <a:r>
+              <a:rPr dirty="0"/>
               <a:t>Outputs (O):     Instant Student Scorecards, Class Submission Gradebook, Proctor Violation Audit Trails, DB Backups.</a:t>
             </a:r>
           </a:p>
@@ -14717,6 +15190,7 @@
               </a:defRPr>
             </a:pPr>
             <a:r>
+              <a:rPr dirty="0"/>
               <a:t>Customers (C):   Enrolled Students (instant feedback), Course Teachers (zero manual grading), Institutional Auditors.</a:t>
             </a:r>
           </a:p>
@@ -14731,7 +15205,7 @@
 </file>
 
 <file path=ppt/slides/slide6.xml><?xml version="1.0" encoding="utf-8"?>
-<p:sld xmlns:a="http://schemas.openxmlformats.org/drawingml/2006/main" xmlns:p="http://schemas.openxmlformats.org/presentationml/2006/main" xmlns:r="http://schemas.openxmlformats.org/officeDocument/2006/relationships">
+<p:sld xmlns:a="http://schemas.openxmlformats.org/drawingml/2006/main" xmlns:r="http://schemas.openxmlformats.org/officeDocument/2006/relationships" xmlns:p="http://schemas.openxmlformats.org/presentationml/2006/main">
   <p:cSld>
     <p:spTree>
       <p:nvGrpSpPr>
@@ -14739,7 +15213,14 @@
         <p:cNvGrpSpPr/>
         <p:nvPr/>
       </p:nvGrpSpPr>
-      <p:grpSpPr/>
+      <p:grpSpPr>
+        <a:xfrm>
+          <a:off x="0" y="0"/>
+          <a:ext cx="0" cy="0"/>
+          <a:chOff x="0" y="0"/>
+          <a:chExt cx="0" cy="0"/>
+        </a:xfrm>
+      </p:grpSpPr>
       <p:sp>
         <p:nvSpPr>
           <p:cNvPr id="2" name="Rectangle 1"/>
@@ -14780,6 +15261,7 @@
           <a:lstStyle/>
           <a:p>
             <a:pPr algn="ctr"/>
+            <a:endParaRPr/>
           </a:p>
         </p:txBody>
       </p:sp>
@@ -14848,6 +15330,7 @@
               </a:defRPr>
             </a:pPr>
             <a:r>
+              <a:rPr dirty="0"/>
               <a:t>Scope &amp; Role-Based Access Control (RBAC)</a:t>
             </a:r>
           </a:p>
@@ -14930,6 +15413,7 @@
           <a:lstStyle/>
           <a:p>
             <a:pPr algn="ctr"/>
+            <a:endParaRPr/>
           </a:p>
         </p:txBody>
       </p:sp>
@@ -14973,6 +15457,7 @@
           <a:lstStyle/>
           <a:p>
             <a:pPr algn="ctr"/>
+            <a:endParaRPr/>
           </a:p>
         </p:txBody>
       </p:sp>
@@ -14984,7 +15469,7 @@
         </p:nvSpPr>
         <p:spPr>
           <a:xfrm>
-            <a:off x="914400" y="1828800"/>
+            <a:off x="1084629" y="2034540"/>
             <a:ext cx="3108960" cy="4114800"/>
           </a:xfrm>
           <a:prstGeom prst="rect">
@@ -15006,6 +15491,7 @@
               </a:defRPr>
             </a:pPr>
             <a:r>
+              <a:rPr dirty="0"/>
               <a:t>STUDENT / CANDIDATE</a:t>
             </a:r>
           </a:p>
@@ -15021,6 +15507,7 @@
               </a:defRPr>
             </a:pPr>
             <a:r>
+              <a:rPr dirty="0"/>
               <a:t>Portal: Candidate Arena</a:t>
             </a:r>
           </a:p>
@@ -15036,6 +15523,7 @@
               </a:defRPr>
             </a:pPr>
             <a:r>
+              <a:rPr dirty="0"/>
               <a:t>• Join assessments via 6-character code (e.g. QZ-1001)</a:t>
             </a:r>
           </a:p>
@@ -15051,6 +15539,7 @@
               </a:defRPr>
             </a:pPr>
             <a:r>
+              <a:rPr dirty="0"/>
               <a:t>• Authoritative countdown timer with zero client drift</a:t>
             </a:r>
           </a:p>
@@ -15066,6 +15555,7 @@
               </a:defRPr>
             </a:pPr>
             <a:r>
+              <a:rPr dirty="0"/>
               <a:t>• Active Anti-Cheat window focus &amp; blur detection</a:t>
             </a:r>
           </a:p>
@@ -15081,6 +15571,7 @@
               </a:defRPr>
             </a:pPr>
             <a:r>
+              <a:rPr dirty="0"/>
               <a:t>• Instant scorecards with question-by-question explanations</a:t>
             </a:r>
           </a:p>
@@ -15096,6 +15587,7 @@
               </a:defRPr>
             </a:pPr>
             <a:r>
+              <a:rPr dirty="0"/>
               <a:t>• Restricted: Examiner Studio &amp; Admin Panel completely hidden</a:t>
             </a:r>
           </a:p>
@@ -15143,6 +15635,7 @@
           <a:lstStyle/>
           <a:p>
             <a:pPr algn="ctr"/>
+            <a:endParaRPr/>
           </a:p>
         </p:txBody>
       </p:sp>
@@ -15186,6 +15679,7 @@
           <a:lstStyle/>
           <a:p>
             <a:pPr algn="ctr"/>
+            <a:endParaRPr/>
           </a:p>
         </p:txBody>
       </p:sp>
@@ -15219,6 +15713,7 @@
               </a:defRPr>
             </a:pPr>
             <a:r>
+              <a:rPr dirty="0"/>
               <a:t>FACULTY / EXAMINER</a:t>
             </a:r>
           </a:p>
@@ -15234,6 +15729,7 @@
               </a:defRPr>
             </a:pPr>
             <a:r>
+              <a:rPr dirty="0"/>
               <a:t>Portal: Examiner Studio</a:t>
             </a:r>
           </a:p>
@@ -15249,6 +15745,7 @@
               </a:defRPr>
             </a:pPr>
             <a:r>
+              <a:rPr dirty="0"/>
               <a:t>• Manual quiz authoring with custom time limits &amp; passing marks</a:t>
             </a:r>
           </a:p>
@@ -15264,6 +15761,7 @@
               </a:defRPr>
             </a:pPr>
             <a:r>
+              <a:rPr dirty="0"/>
               <a:t>• AI-assisted curriculum generation based on topic &amp; difficulty</a:t>
             </a:r>
           </a:p>
@@ -15279,6 +15777,7 @@
               </a:defRPr>
             </a:pPr>
             <a:r>
+              <a:rPr dirty="0"/>
               <a:t>• Instant Join Code generation for fast student distribution</a:t>
             </a:r>
           </a:p>
@@ -15294,6 +15793,7 @@
               </a:defRPr>
             </a:pPr>
             <a:r>
+              <a:rPr dirty="0"/>
               <a:t>• Live Class Gradebook with student scores &amp; violation tallies</a:t>
             </a:r>
           </a:p>
@@ -15309,6 +15809,7 @@
               </a:defRPr>
             </a:pPr>
             <a:r>
+              <a:rPr dirty="0"/>
               <a:t>• Restricted: Admin governance panel hidden</a:t>
             </a:r>
           </a:p>
@@ -15356,6 +15857,7 @@
           <a:lstStyle/>
           <a:p>
             <a:pPr algn="ctr"/>
+            <a:endParaRPr/>
           </a:p>
         </p:txBody>
       </p:sp>
@@ -15399,6 +15901,7 @@
           <a:lstStyle/>
           <a:p>
             <a:pPr algn="ctr"/>
+            <a:endParaRPr/>
           </a:p>
         </p:txBody>
       </p:sp>
@@ -15432,6 +15935,7 @@
               </a:defRPr>
             </a:pPr>
             <a:r>
+              <a:rPr dirty="0"/>
               <a:t>ADMINISTRATOR</a:t>
             </a:r>
           </a:p>
@@ -15447,6 +15951,7 @@
               </a:defRPr>
             </a:pPr>
             <a:r>
+              <a:rPr dirty="0"/>
               <a:t>Portal: Platform Admin Console</a:t>
             </a:r>
           </a:p>
@@ -15462,6 +15967,7 @@
               </a:defRPr>
             </a:pPr>
             <a:r>
+              <a:rPr dirty="0"/>
               <a:t>• Platform telemetry (total users, active faculty, attempt counts)</a:t>
             </a:r>
           </a:p>
@@ -15477,6 +15983,7 @@
               </a:defRPr>
             </a:pPr>
             <a:r>
+              <a:rPr dirty="0"/>
               <a:t>• User governance roster with search &amp; role filters</a:t>
             </a:r>
           </a:p>
@@ -15492,6 +15999,7 @@
               </a:defRPr>
             </a:pPr>
             <a:r>
+              <a:rPr dirty="0"/>
               <a:t>• Candidate Performance Scorecard drill-down modal</a:t>
             </a:r>
           </a:p>
@@ -15507,6 +16015,7 @@
               </a:defRPr>
             </a:pPr>
             <a:r>
+              <a:rPr dirty="0"/>
               <a:t>• Instant CSV exports for rosters and complete audit logs</a:t>
             </a:r>
           </a:p>
@@ -15522,6 +16031,7 @@
               </a:defRPr>
             </a:pPr>
             <a:r>
+              <a:rPr dirty="0"/>
               <a:t>• Database integrity monitoring and backup snapshot triggers</a:t>
             </a:r>
           </a:p>
@@ -15536,7 +16046,7 @@
 </file>
 
 <file path=ppt/slides/slide7.xml><?xml version="1.0" encoding="utf-8"?>
-<p:sld xmlns:a="http://schemas.openxmlformats.org/drawingml/2006/main" xmlns:p="http://schemas.openxmlformats.org/presentationml/2006/main" xmlns:r="http://schemas.openxmlformats.org/officeDocument/2006/relationships">
+<p:sld xmlns:a="http://schemas.openxmlformats.org/drawingml/2006/main" xmlns:r="http://schemas.openxmlformats.org/officeDocument/2006/relationships" xmlns:p="http://schemas.openxmlformats.org/presentationml/2006/main">
   <p:cSld>
     <p:spTree>
       <p:nvGrpSpPr>
@@ -15544,7 +16054,14 @@
         <p:cNvGrpSpPr/>
         <p:nvPr/>
       </p:nvGrpSpPr>
-      <p:grpSpPr/>
+      <p:grpSpPr>
+        <a:xfrm>
+          <a:off x="0" y="0"/>
+          <a:ext cx="0" cy="0"/>
+          <a:chOff x="0" y="0"/>
+          <a:chExt cx="0" cy="0"/>
+        </a:xfrm>
+      </p:grpSpPr>
       <p:sp>
         <p:nvSpPr>
           <p:cNvPr id="2" name="Rectangle 1"/>
@@ -15585,6 +16102,7 @@
           <a:lstStyle/>
           <a:p>
             <a:pPr algn="ctr"/>
+            <a:endParaRPr/>
           </a:p>
         </p:txBody>
       </p:sp>
@@ -15653,6 +16171,7 @@
               </a:defRPr>
             </a:pPr>
             <a:r>
+              <a:rPr dirty="0"/>
               <a:t>SRS &amp; Measurable Requirements (Need → Number We Can Count)</a:t>
             </a:r>
           </a:p>
@@ -15735,6 +16254,7 @@
           <a:lstStyle/>
           <a:p>
             <a:pPr algn="ctr"/>
+            <a:endParaRPr/>
           </a:p>
         </p:txBody>
       </p:sp>
@@ -15778,6 +16298,7 @@
           <a:lstStyle/>
           <a:p>
             <a:pPr algn="ctr"/>
+            <a:endParaRPr/>
           </a:p>
         </p:txBody>
       </p:sp>
@@ -15814,6 +16335,7 @@
               </a:defRPr>
             </a:pPr>
             <a:r>
+              <a:rPr dirty="0"/>
               <a:t>FORMAL SRS SPECIFICATION (IEEE 830)</a:t>
             </a:r>
           </a:p>
@@ -15822,13 +16344,14 @@
               <a:spcBef>
                 <a:spcPts val="300"/>
               </a:spcBef>
-              <a:defRPr b="1" sz="1050">
+              <a:defRPr sz="1050" b="1">
                 <a:solidFill>
                   <a:srgbClr val="FFFFFF"/>
                 </a:solidFill>
               </a:defRPr>
             </a:pPr>
             <a:r>
+              <a:rPr dirty="0"/>
               <a:t>• Standard Compliance:</a:t>
             </a:r>
           </a:p>
@@ -15841,6 +16364,7 @@
               </a:defRPr>
             </a:pPr>
             <a:r>
+              <a:rPr dirty="0"/>
               <a:t>  Structured per IEEE 830 in docs/SRS_Document.md.</a:t>
             </a:r>
           </a:p>
@@ -15849,13 +16373,14 @@
               <a:spcBef>
                 <a:spcPts val="300"/>
               </a:spcBef>
-              <a:defRPr b="1" sz="1050">
+              <a:defRPr sz="1050" b="1">
                 <a:solidFill>
                   <a:srgbClr val="FFFFFF"/>
                 </a:solidFill>
               </a:defRPr>
             </a:pPr>
             <a:r>
+              <a:rPr dirty="0"/>
               <a:t>• System Boundaries:</a:t>
             </a:r>
           </a:p>
@@ -15868,6 +16393,7 @@
               </a:defRPr>
             </a:pPr>
             <a:r>
+              <a:rPr dirty="0"/>
               <a:t>  Covers Student examinees, Faculty authors, and System Admins.</a:t>
             </a:r>
           </a:p>
@@ -15876,13 +16402,14 @@
               <a:spcBef>
                 <a:spcPts val="300"/>
               </a:spcBef>
-              <a:defRPr b="1" sz="1050">
+              <a:defRPr sz="1050" b="1">
                 <a:solidFill>
                   <a:srgbClr val="FFFFFF"/>
                 </a:solidFill>
               </a:defRPr>
             </a:pPr>
             <a:r>
+              <a:rPr dirty="0"/>
               <a:t>• Multi-Tier Isolation:</a:t>
             </a:r>
           </a:p>
@@ -15895,7 +16422,16 @@
               </a:defRPr>
             </a:pPr>
             <a:r>
-              <a:t>  Presentation SPA / GUI, FastAPI Service Layer, SQLite Persistence.</a:t>
+              <a:rPr dirty="0"/>
+              <a:t>  Presentation SPA / GUI, </a:t>
+            </a:r>
+            <a:r>
+              <a:rPr dirty="0" err="1"/>
+              <a:t>FastAPI</a:t>
+            </a:r>
+            <a:r>
+              <a:rPr dirty="0"/>
+              <a:t> Service Layer, SQLite Persistence.</a:t>
             </a:r>
           </a:p>
           <a:p>
@@ -15903,13 +16439,14 @@
               <a:spcBef>
                 <a:spcPts val="300"/>
               </a:spcBef>
-              <a:defRPr b="1" sz="1050">
+              <a:defRPr sz="1050" b="1">
                 <a:solidFill>
                   <a:srgbClr val="FFFFFF"/>
                 </a:solidFill>
               </a:defRPr>
             </a:pPr>
             <a:r>
+              <a:rPr dirty="0"/>
               <a:t>• Poka-Yoke Validation:</a:t>
             </a:r>
           </a:p>
@@ -15922,7 +16459,16 @@
               </a:defRPr>
             </a:pPr>
             <a:r>
-              <a:t>  Pydantic v2 schemas reject out-of-bounds input at the API boundary.</a:t>
+              <a:rPr dirty="0"/>
+              <a:t>  </a:t>
+            </a:r>
+            <a:r>
+              <a:rPr dirty="0" err="1"/>
+              <a:t>Pydantic</a:t>
+            </a:r>
+            <a:r>
+              <a:rPr dirty="0"/>
+              <a:t> v2 schemas reject out-of-bounds input at the API boundary.</a:t>
             </a:r>
           </a:p>
           <a:p>
@@ -15930,13 +16476,14 @@
               <a:spcBef>
                 <a:spcPts val="300"/>
               </a:spcBef>
-              <a:defRPr b="1" sz="1050">
+              <a:defRPr sz="1050" b="1">
                 <a:solidFill>
                   <a:srgbClr val="FFFFFF"/>
                 </a:solidFill>
               </a:defRPr>
             </a:pPr>
             <a:r>
+              <a:rPr dirty="0"/>
               <a:t>• Zero-Defect Quality Goal:</a:t>
             </a:r>
           </a:p>
@@ -15949,6 +16496,7 @@
               </a:defRPr>
             </a:pPr>
             <a:r>
+              <a:rPr dirty="0"/>
               <a:t>  Meets Q20 overall quality mandate with 22/22 unit tests passing.</a:t>
             </a:r>
           </a:p>
@@ -15996,6 +16544,7 @@
           <a:lstStyle/>
           <a:p>
             <a:pPr algn="ctr"/>
+            <a:endParaRPr/>
           </a:p>
         </p:txBody>
       </p:sp>
@@ -16039,6 +16588,7 @@
           <a:lstStyle/>
           <a:p>
             <a:pPr algn="ctr"/>
+            <a:endParaRPr/>
           </a:p>
         </p:txBody>
       </p:sp>
@@ -16075,6 +16625,7 @@
               </a:defRPr>
             </a:pPr>
             <a:r>
+              <a:rPr dirty="0"/>
               <a:t>MEASURABLE REQUIREMENTS (VIVA FORMULA)</a:t>
             </a:r>
           </a:p>
@@ -16083,13 +16634,14 @@
               <a:spcBef>
                 <a:spcPts val="300"/>
               </a:spcBef>
-              <a:defRPr b="1" sz="1050">
+              <a:defRPr sz="1050" b="1">
                 <a:solidFill>
                   <a:srgbClr val="F59E0B"/>
                 </a:solidFill>
               </a:defRPr>
             </a:pPr>
             <a:r>
+              <a:rPr dirty="0"/>
               <a:t>✔ Zero Lost Submissions:</a:t>
             </a:r>
           </a:p>
@@ -16102,6 +16654,7 @@
               </a:defRPr>
             </a:pPr>
             <a:r>
+              <a:rPr dirty="0"/>
               <a:t>   Target: Lost submissions count = 0 (100% captured)</a:t>
             </a:r>
           </a:p>
@@ -16110,13 +16663,14 @@
               <a:spcBef>
                 <a:spcPts val="300"/>
               </a:spcBef>
-              <a:defRPr b="1" sz="1050">
+              <a:defRPr sz="1050" b="1">
                 <a:solidFill>
                   <a:srgbClr val="F59E0B"/>
                 </a:solidFill>
               </a:defRPr>
             </a:pPr>
             <a:r>
+              <a:rPr dirty="0"/>
               <a:t>✔ Zero Grading Latency:</a:t>
             </a:r>
           </a:p>
@@ -16129,7 +16683,24 @@
               </a:defRPr>
             </a:pPr>
             <a:r>
-              <a:t>   Target: Turnaround time &lt; 250 ms (achieved ~25 ms)</a:t>
+              <a:rPr dirty="0"/>
+              <a:t>   Target: Turnaround time &lt; 250 </a:t>
+            </a:r>
+            <a:r>
+              <a:rPr dirty="0" err="1"/>
+              <a:t>ms</a:t>
+            </a:r>
+            <a:r>
+              <a:rPr dirty="0"/>
+              <a:t> (achieved ~25 </a:t>
+            </a:r>
+            <a:r>
+              <a:rPr dirty="0" err="1"/>
+              <a:t>ms</a:t>
+            </a:r>
+            <a:r>
+              <a:rPr dirty="0"/>
+              <a:t>)</a:t>
             </a:r>
           </a:p>
           <a:p>
@@ -16137,13 +16708,14 @@
               <a:spcBef>
                 <a:spcPts val="300"/>
               </a:spcBef>
-              <a:defRPr b="1" sz="1050">
+              <a:defRPr sz="1050" b="1">
                 <a:solidFill>
                   <a:srgbClr val="F59E0B"/>
                 </a:solidFill>
               </a:defRPr>
             </a:pPr>
             <a:r>
+              <a:rPr dirty="0"/>
               <a:t>✔ 100% Grading Accuracy:</a:t>
             </a:r>
           </a:p>
@@ -16156,6 +16728,7 @@
               </a:defRPr>
             </a:pPr>
             <a:r>
+              <a:rPr dirty="0"/>
               <a:t>   Target: Calculated score vs key = 100.0% match</a:t>
             </a:r>
           </a:p>
@@ -16164,13 +16737,14 @@
               <a:spcBef>
                 <a:spcPts val="300"/>
               </a:spcBef>
-              <a:defRPr b="1" sz="1050">
+              <a:defRPr sz="1050" b="1">
                 <a:solidFill>
                   <a:srgbClr val="F59E0B"/>
                 </a:solidFill>
               </a:defRPr>
             </a:pPr>
             <a:r>
+              <a:rPr dirty="0"/>
               <a:t>✔ Anti-Cheat Tracking:</a:t>
             </a:r>
           </a:p>
@@ -16183,6 +16757,7 @@
               </a:defRPr>
             </a:pPr>
             <a:r>
+              <a:rPr dirty="0"/>
               <a:t>   Target: Focus loss / tab switches logged = 100%</a:t>
             </a:r>
           </a:p>
@@ -16191,13 +16766,14 @@
               <a:spcBef>
                 <a:spcPts val="300"/>
               </a:spcBef>
-              <a:defRPr b="1" sz="1050">
+              <a:defRPr sz="1050" b="1">
                 <a:solidFill>
                   <a:srgbClr val="F59E0B"/>
                 </a:solidFill>
               </a:defRPr>
             </a:pPr>
             <a:r>
+              <a:rPr dirty="0"/>
               <a:t>✔ Fast Join Code Lookup:</a:t>
             </a:r>
           </a:p>
@@ -16210,6 +16786,7 @@
               </a:defRPr>
             </a:pPr>
             <a:r>
+              <a:rPr dirty="0"/>
               <a:t>   Target: Resolution time &lt; 25 milliseconds</a:t>
             </a:r>
           </a:p>
@@ -16218,13 +16795,14 @@
               <a:spcBef>
                 <a:spcPts val="300"/>
               </a:spcBef>
-              <a:defRPr b="1" sz="1050">
+              <a:defRPr sz="1050" b="1">
                 <a:solidFill>
                   <a:srgbClr val="F59E0B"/>
                 </a:solidFill>
               </a:defRPr>
             </a:pPr>
             <a:r>
+              <a:rPr dirty="0"/>
               <a:t>✔ Data Protection (RPO):</a:t>
             </a:r>
           </a:p>
@@ -16237,6 +16815,7 @@
               </a:defRPr>
             </a:pPr>
             <a:r>
+              <a:rPr dirty="0"/>
               <a:t>   Target: Automated DB snapshot frequency &lt;= 1 hour</a:t>
             </a:r>
           </a:p>
@@ -16251,7 +16830,7 @@
 </file>
 
 <file path=ppt/slides/slide8.xml><?xml version="1.0" encoding="utf-8"?>
-<p:sld xmlns:a="http://schemas.openxmlformats.org/drawingml/2006/main" xmlns:p="http://schemas.openxmlformats.org/presentationml/2006/main" xmlns:r="http://schemas.openxmlformats.org/officeDocument/2006/relationships">
+<p:sld xmlns:a="http://schemas.openxmlformats.org/drawingml/2006/main" xmlns:r="http://schemas.openxmlformats.org/officeDocument/2006/relationships" xmlns:p="http://schemas.openxmlformats.org/presentationml/2006/main">
   <p:cSld>
     <p:spTree>
       <p:nvGrpSpPr>
@@ -16259,7 +16838,14 @@
         <p:cNvGrpSpPr/>
         <p:nvPr/>
       </p:nvGrpSpPr>
-      <p:grpSpPr/>
+      <p:grpSpPr>
+        <a:xfrm>
+          <a:off x="0" y="0"/>
+          <a:ext cx="0" cy="0"/>
+          <a:chOff x="0" y="0"/>
+          <a:chExt cx="0" cy="0"/>
+        </a:xfrm>
+      </p:grpSpPr>
       <p:sp>
         <p:nvSpPr>
           <p:cNvPr id="2" name="Rectangle 1"/>
@@ -16300,6 +16886,7 @@
           <a:lstStyle/>
           <a:p>
             <a:pPr algn="ctr"/>
+            <a:endParaRPr/>
           </a:p>
         </p:txBody>
       </p:sp>
@@ -16368,6 +16955,7 @@
               </a:defRPr>
             </a:pPr>
             <a:r>
+              <a:rPr dirty="0"/>
               <a:t>Modular Folder Architecture &amp; The Golden Rule</a:t>
             </a:r>
           </a:p>
@@ -16450,6 +17038,7 @@
           <a:lstStyle/>
           <a:p>
             <a:pPr algn="ctr"/>
+            <a:endParaRPr/>
           </a:p>
         </p:txBody>
       </p:sp>
@@ -16493,6 +17082,7 @@
           <a:lstStyle/>
           <a:p>
             <a:pPr algn="ctr"/>
+            <a:endParaRPr/>
           </a:p>
         </p:txBody>
       </p:sp>
@@ -16526,6 +17116,7 @@
               </a:defRPr>
             </a:pPr>
             <a:r>
+              <a:rPr dirty="0"/>
               <a:t>THE ONE RULE TO REMEMBER: The screen must not talk to the database.</a:t>
             </a:r>
           </a:p>
@@ -16541,6 +17132,7 @@
               </a:defRPr>
             </a:pPr>
             <a:r>
+              <a:rPr dirty="0"/>
               <a:t>UI  →  Service  →  Model / Database  (No raw SQL queries inside UI button callbacks or templates)</a:t>
             </a:r>
           </a:p>
@@ -16588,6 +17180,7 @@
           <a:lstStyle/>
           <a:p>
             <a:pPr algn="ctr"/>
+            <a:endParaRPr/>
           </a:p>
         </p:txBody>
       </p:sp>
@@ -16631,6 +17224,7 @@
           <a:lstStyle/>
           <a:p>
             <a:pPr algn="ctr"/>
+            <a:endParaRPr/>
           </a:p>
         </p:txBody>
       </p:sp>
@@ -16642,7 +17236,7 @@
         </p:nvSpPr>
         <p:spPr>
           <a:xfrm>
-            <a:off x="914400" y="2971800"/>
+            <a:off x="828135" y="3008376"/>
             <a:ext cx="3108960" cy="3017520"/>
           </a:xfrm>
           <a:prstGeom prst="rect">
@@ -16667,6 +17261,7 @@
               </a:defRPr>
             </a:pPr>
             <a:r>
+              <a:rPr dirty="0"/>
               <a:t>CORE &amp; DATABASE</a:t>
             </a:r>
           </a:p>
@@ -16682,7 +17277,16 @@
               </a:defRPr>
             </a:pPr>
             <a:r>
-              <a:t>• server.py: Starts app, FastAPI lifespan</a:t>
+              <a:rPr dirty="0"/>
+              <a:t>• server.py: Starts app, </a:t>
+            </a:r>
+            <a:r>
+              <a:rPr dirty="0" err="1"/>
+              <a:t>FastAPI</a:t>
+            </a:r>
+            <a:r>
+              <a:rPr dirty="0"/>
+              <a:t> lifespan</a:t>
             </a:r>
           </a:p>
           <a:p>
@@ -16697,6 +17301,7 @@
               </a:defRPr>
             </a:pPr>
             <a:r>
+              <a:rPr dirty="0"/>
               <a:t>• desktop_app.py: Standalone Windows GUI</a:t>
             </a:r>
           </a:p>
@@ -16712,6 +17317,7 @@
               </a:defRPr>
             </a:pPr>
             <a:r>
+              <a:rPr dirty="0"/>
               <a:t>• database/db.py: Opens SQLite &amp; commits</a:t>
             </a:r>
           </a:p>
@@ -16727,6 +17333,7 @@
               </a:defRPr>
             </a:pPr>
             <a:r>
+              <a:rPr dirty="0"/>
               <a:t>• database/schema.py: Table definitions</a:t>
             </a:r>
           </a:p>
@@ -16742,6 +17349,7 @@
               </a:defRPr>
             </a:pPr>
             <a:r>
+              <a:rPr dirty="0"/>
               <a:t>• database/migrations.py: Safe schema upgrades</a:t>
             </a:r>
           </a:p>
@@ -16789,6 +17397,7 @@
           <a:lstStyle/>
           <a:p>
             <a:pPr algn="ctr"/>
+            <a:endParaRPr/>
           </a:p>
         </p:txBody>
       </p:sp>
@@ -16832,6 +17441,7 @@
           <a:lstStyle/>
           <a:p>
             <a:pPr algn="ctr"/>
+            <a:endParaRPr/>
           </a:p>
         </p:txBody>
       </p:sp>
@@ -16843,7 +17453,7 @@
         </p:nvSpPr>
         <p:spPr>
           <a:xfrm>
-            <a:off x="4526280" y="2971800"/>
+            <a:off x="4777740" y="3246120"/>
             <a:ext cx="3108960" cy="3017520"/>
           </a:xfrm>
           <a:prstGeom prst="rect">
@@ -16868,6 +17478,7 @@
               </a:defRPr>
             </a:pPr>
             <a:r>
+              <a:rPr dirty="0"/>
               <a:t>SERVICES &amp; MODELS</a:t>
             </a:r>
           </a:p>
@@ -16883,6 +17494,7 @@
               </a:defRPr>
             </a:pPr>
             <a:r>
+              <a:rPr dirty="0"/>
               <a:t>• services/auth_service.py: Login &amp; RBAC</a:t>
             </a:r>
           </a:p>
@@ -16898,6 +17510,7 @@
               </a:defRPr>
             </a:pPr>
             <a:r>
+              <a:rPr dirty="0"/>
               <a:t>• services/quiz_service.py: Create &amp; Join Code</a:t>
             </a:r>
           </a:p>
@@ -16913,6 +17526,7 @@
               </a:defRPr>
             </a:pPr>
             <a:r>
+              <a:rPr dirty="0"/>
               <a:t>• services/grading_service.py: Sub-250ms score</a:t>
             </a:r>
           </a:p>
@@ -16928,6 +17542,7 @@
               </a:defRPr>
             </a:pPr>
             <a:r>
+              <a:rPr dirty="0"/>
               <a:t>• services/proctor_service.py: Violation tracker</a:t>
             </a:r>
           </a:p>
@@ -16943,6 +17558,7 @@
               </a:defRPr>
             </a:pPr>
             <a:r>
+              <a:rPr dirty="0"/>
               <a:t>• models/ (user.py, quiz.py, attempt.py)</a:t>
             </a:r>
           </a:p>
@@ -16990,6 +17606,7 @@
           <a:lstStyle/>
           <a:p>
             <a:pPr algn="ctr"/>
+            <a:endParaRPr/>
           </a:p>
         </p:txBody>
       </p:sp>
@@ -17033,6 +17650,7 @@
           <a:lstStyle/>
           <a:p>
             <a:pPr algn="ctr"/>
+            <a:endParaRPr/>
           </a:p>
         </p:txBody>
       </p:sp>
@@ -17069,6 +17687,7 @@
               </a:defRPr>
             </a:pPr>
             <a:r>
+              <a:rPr dirty="0"/>
               <a:t>UI, UTILS &amp; REPORTS</a:t>
             </a:r>
           </a:p>
@@ -17084,7 +17703,16 @@
               </a:defRPr>
             </a:pPr>
             <a:r>
-              <a:t>• ui/ (Login, Candidate Arena, Examiner Studio)</a:t>
+              <a:rPr dirty="0"/>
+              <a:t>• </a:t>
+            </a:r>
+            <a:r>
+              <a:rPr dirty="0" err="1"/>
+              <a:t>ui</a:t>
+            </a:r>
+            <a:r>
+              <a:rPr dirty="0"/>
+              <a:t>/ (Login, Candidate Arena, Examiner Studio)</a:t>
             </a:r>
           </a:p>
           <a:p>
@@ -17099,6 +17727,7 @@
               </a:defRPr>
             </a:pPr>
             <a:r>
+              <a:rPr dirty="0"/>
               <a:t>• reports/ (Class Gradebook, CSV Exporters)</a:t>
             </a:r>
           </a:p>
@@ -17114,6 +17743,7 @@
               </a:defRPr>
             </a:pPr>
             <a:r>
+              <a:rPr dirty="0"/>
               <a:t>• utils/validators.py: Poka-yoke error prevention</a:t>
             </a:r>
           </a:p>
@@ -17129,8 +17759,14 @@
               </a:defRPr>
             </a:pPr>
             <a:r>
-              <a:t>• utils/logger.py: Telemetry &amp; error_logs</a:t>
-            </a:r>
+              <a:rPr dirty="0"/>
+              <a:t>• utils/logger.py: Telemetry &amp; </a:t>
+            </a:r>
+            <a:r>
+              <a:rPr dirty="0" err="1"/>
+              <a:t>error_logs</a:t>
+            </a:r>
+            <a:endParaRPr dirty="0"/>
           </a:p>
           <a:p>
             <a:pPr>
@@ -17144,7 +17780,16 @@
               </a:defRPr>
             </a:pPr>
             <a:r>
-              <a:t>• tests/ (22 automated Pytest unit tests)</a:t>
+              <a:rPr dirty="0"/>
+              <a:t>• tests/ (22 automated </a:t>
+            </a:r>
+            <a:r>
+              <a:rPr dirty="0" err="1"/>
+              <a:t>Pytest</a:t>
+            </a:r>
+            <a:r>
+              <a:rPr dirty="0"/>
+              <a:t> unit tests)</a:t>
             </a:r>
           </a:p>
         </p:txBody>
@@ -17158,7 +17803,7 @@
 </file>
 
 <file path=ppt/slides/slide9.xml><?xml version="1.0" encoding="utf-8"?>
-<p:sld xmlns:a="http://schemas.openxmlformats.org/drawingml/2006/main" xmlns:p="http://schemas.openxmlformats.org/presentationml/2006/main" xmlns:r="http://schemas.openxmlformats.org/officeDocument/2006/relationships">
+<p:sld xmlns:a="http://schemas.openxmlformats.org/drawingml/2006/main" xmlns:r="http://schemas.openxmlformats.org/officeDocument/2006/relationships" xmlns:p="http://schemas.openxmlformats.org/presentationml/2006/main">
   <p:cSld>
     <p:spTree>
       <p:nvGrpSpPr>
@@ -17166,7 +17811,14 @@
         <p:cNvGrpSpPr/>
         <p:nvPr/>
       </p:nvGrpSpPr>
-      <p:grpSpPr/>
+      <p:grpSpPr>
+        <a:xfrm>
+          <a:off x="0" y="0"/>
+          <a:ext cx="0" cy="0"/>
+          <a:chOff x="0" y="0"/>
+          <a:chExt cx="0" cy="0"/>
+        </a:xfrm>
+      </p:grpSpPr>
       <p:sp>
         <p:nvSpPr>
           <p:cNvPr id="2" name="Rectangle 1"/>
@@ -17207,6 +17859,7 @@
           <a:lstStyle/>
           <a:p>
             <a:pPr algn="ctr"/>
+            <a:endParaRPr/>
           </a:p>
         </p:txBody>
       </p:sp>
@@ -17275,6 +17928,7 @@
               </a:defRPr>
             </a:pPr>
             <a:r>
+              <a:rPr dirty="0"/>
               <a:t>Core Modules &amp; Feature Breakdown</a:t>
             </a:r>
           </a:p>
@@ -17357,6 +18011,7 @@
           <a:lstStyle/>
           <a:p>
             <a:pPr algn="ctr"/>
+            <a:endParaRPr/>
           </a:p>
         </p:txBody>
       </p:sp>
@@ -17400,6 +18055,7 @@
           <a:lstStyle/>
           <a:p>
             <a:pPr algn="ctr"/>
+            <a:endParaRPr/>
           </a:p>
         </p:txBody>
       </p:sp>
@@ -17411,7 +18067,7 @@
         </p:nvSpPr>
         <p:spPr>
           <a:xfrm>
-            <a:off x="914400" y="1828800"/>
+            <a:off x="914400" y="1901951"/>
             <a:ext cx="3108960" cy="1783080"/>
           </a:xfrm>
           <a:prstGeom prst="rect">
@@ -17436,6 +18092,7 @@
               </a:defRPr>
             </a:pPr>
             <a:r>
+              <a:rPr dirty="0"/>
               <a:t>M1: Identity &amp; Authentication</a:t>
             </a:r>
           </a:p>
@@ -17448,6 +18105,7 @@
               </a:defRPr>
             </a:pPr>
             <a:r>
+              <a:rPr dirty="0"/>
               <a:t>Secure login/signup for Student, Faculty, Admin. Dynamic navigation tab visibility based on authenticated role.</a:t>
             </a:r>
           </a:p>
@@ -17495,6 +18153,7 @@
           <a:lstStyle/>
           <a:p>
             <a:pPr algn="ctr"/>
+            <a:endParaRPr/>
           </a:p>
         </p:txBody>
       </p:sp>
@@ -17538,6 +18197,7 @@
           <a:lstStyle/>
           <a:p>
             <a:pPr algn="ctr"/>
+            <a:endParaRPr/>
           </a:p>
         </p:txBody>
       </p:sp>
@@ -17574,6 +18234,7 @@
               </a:defRPr>
             </a:pPr>
             <a:r>
+              <a:rPr dirty="0"/>
               <a:t>M2: Examiner Studio &amp; AI Wizard</a:t>
             </a:r>
           </a:p>
@@ -17586,6 +18247,7 @@
               </a:defRPr>
             </a:pPr>
             <a:r>
+              <a:rPr dirty="0"/>
               <a:t>Manual quiz authoring or AI syllabus synthesis. Configures time limits, passing mark, and unique 6-character Join Code.</a:t>
             </a:r>
           </a:p>
@@ -17633,6 +18295,7 @@
           <a:lstStyle/>
           <a:p>
             <a:pPr algn="ctr"/>
+            <a:endParaRPr/>
           </a:p>
         </p:txBody>
       </p:sp>
@@ -17676,6 +18339,7 @@
           <a:lstStyle/>
           <a:p>
             <a:pPr algn="ctr"/>
+            <a:endParaRPr/>
           </a:p>
         </p:txBody>
       </p:sp>
@@ -17712,6 +18376,7 @@
               </a:defRPr>
             </a:pPr>
             <a:r>
+              <a:rPr dirty="0"/>
               <a:t>M3: Candidate Assessment Arena</a:t>
             </a:r>
           </a:p>
@@ -17724,6 +18389,7 @@
               </a:defRPr>
             </a:pPr>
             <a:r>
+              <a:rPr dirty="0"/>
               <a:t>Quick test join via code. Delivers questions with interactive palette, authoritative server countdown timer, and auto-submit.</a:t>
             </a:r>
           </a:p>
@@ -17771,6 +18437,7 @@
           <a:lstStyle/>
           <a:p>
             <a:pPr algn="ctr"/>
+            <a:endParaRPr/>
           </a:p>
         </p:txBody>
       </p:sp>
@@ -17814,6 +18481,7 @@
           <a:lstStyle/>
           <a:p>
             <a:pPr algn="ctr"/>
+            <a:endParaRPr/>
           </a:p>
         </p:txBody>
       </p:sp>
@@ -17850,6 +18518,7 @@
               </a:defRPr>
             </a:pPr>
             <a:r>
+              <a:rPr dirty="0"/>
               <a:t>M4: Anti-Cheat Proctoring Hub</a:t>
             </a:r>
           </a:p>
@@ -17862,6 +18531,7 @@
               </a:defRPr>
             </a:pPr>
             <a:r>
+              <a:rPr dirty="0"/>
               <a:t>Continuous window focus tracking monitors tab switches and window blur events, incrementing violation tallies in real time.</a:t>
             </a:r>
           </a:p>
@@ -17909,6 +18579,7 @@
           <a:lstStyle/>
           <a:p>
             <a:pPr algn="ctr"/>
+            <a:endParaRPr/>
           </a:p>
         </p:txBody>
       </p:sp>
@@ -17952,6 +18623,7 @@
           <a:lstStyle/>
           <a:p>
             <a:pPr algn="ctr"/>
+            <a:endParaRPr/>
           </a:p>
         </p:txBody>
       </p:sp>
@@ -17963,7 +18635,7 @@
         </p:nvSpPr>
         <p:spPr>
           <a:xfrm>
-            <a:off x="4526280" y="4160519"/>
+            <a:off x="4526280" y="3944600"/>
             <a:ext cx="3108960" cy="1783080"/>
           </a:xfrm>
           <a:prstGeom prst="rect">
@@ -17988,6 +18660,7 @@
               </a:defRPr>
             </a:pPr>
             <a:r>
+              <a:rPr dirty="0"/>
               <a:t>M5: Zero-Latency Auto-Grading</a:t>
             </a:r>
           </a:p>
@@ -18000,6 +18673,7 @@
               </a:defRPr>
             </a:pPr>
             <a:r>
+              <a:rPr dirty="0"/>
               <a:t>In-memory evaluation compares answers against key in ~25ms. Displays immediate scorecard with detailed explanations.</a:t>
             </a:r>
           </a:p>
@@ -18047,6 +18721,7 @@
           <a:lstStyle/>
           <a:p>
             <a:pPr algn="ctr"/>
+            <a:endParaRPr/>
           </a:p>
         </p:txBody>
       </p:sp>
@@ -18090,6 +18765,7 @@
           <a:lstStyle/>
           <a:p>
             <a:pPr algn="ctr"/>
+            <a:endParaRPr/>
           </a:p>
         </p:txBody>
       </p:sp>
@@ -18126,6 +18802,7 @@
               </a:defRPr>
             </a:pPr>
             <a:r>
+              <a:rPr dirty="0"/>
               <a:t>M6: Admin Governance &amp; Telemetry</a:t>
             </a:r>
           </a:p>
@@ -18138,6 +18815,7 @@
               </a:defRPr>
             </a:pPr>
             <a:r>
+              <a:rPr dirty="0"/>
               <a:t>Platform telemetry KPIs, filterable user roster, candidate performance scorecard drill-down modal, and CSV exports.</a:t>
             </a:r>
           </a:p>

</xml_diff>